<commit_message>
Restructure Instagram carousel: text and photo in separate non-overlapping blocks
Each trend card now stacks a fixed text zone and an uninterrupted photo
zone instead of overlaying text on a scrimmed photo, following the
structural pattern of the trends-portal carousel reference (own report
photos and brand identity only, no third-party imagery reused). Adds
the matching Instagram caption text as a delivered file.
</commit_message>
<xml_diff>
--- a/entregas-agosto26/carrossel-instagram-agosto26.pptx
+++ b/entregas-agosto26/carrossel-instagram-agosto26.pptx
@@ -3612,8 +3612,8 @@
         </p:blipFill>
         <p:spPr>
           <a:xfrm>
-            <a:off x="0" y="0"/>
-            <a:ext cx="8229600" cy="10287000"/>
+            <a:off x="0" y="4937760"/>
+            <a:ext cx="8229600" cy="5349240"/>
           </a:xfrm>
           <a:prstGeom prst="rect">
             <a:avLst/>
@@ -3622,29 +3622,7 @@
       </p:pic>
       <p:sp>
         <p:nvSpPr>
-          <p:cNvPr id="3" name="Shape 0"/>
-          <p:cNvSpPr/>
-          <p:nvPr/>
-        </p:nvSpPr>
-        <p:spPr>
-          <a:xfrm>
-            <a:off x="0" y="0"/>
-            <a:ext cx="8229600" cy="4937760"/>
-          </a:xfrm>
-          <a:prstGeom prst="rect">
-            <a:avLst/>
-          </a:prstGeom>
-          <a:solidFill>
-            <a:srgbClr val="000000">
-              <a:alpha val="68000"/>
-            </a:srgbClr>
-          </a:solidFill>
-          <a:ln/>
-        </p:spPr>
-      </p:sp>
-      <p:sp>
-        <p:nvSpPr>
-          <p:cNvPr id="4" name="Text 1"/>
+          <p:cNvPr id="3" name="Text 0"/>
           <p:cNvSpPr/>
           <p:nvPr/>
         </p:nvSpPr>
@@ -3683,7 +3661,7 @@
       </p:sp>
       <p:sp>
         <p:nvSpPr>
-          <p:cNvPr id="5" name="Text 2"/>
+          <p:cNvPr id="4" name="Text 1"/>
           <p:cNvSpPr/>
           <p:nvPr/>
         </p:nvSpPr>
@@ -3722,7 +3700,7 @@
       </p:sp>
       <p:sp>
         <p:nvSpPr>
-          <p:cNvPr id="6" name="Text 3"/>
+          <p:cNvPr id="5" name="Text 2"/>
           <p:cNvSpPr/>
           <p:nvPr/>
         </p:nvSpPr>
@@ -3761,14 +3739,14 @@
       </p:sp>
       <p:sp>
         <p:nvSpPr>
-          <p:cNvPr id="7" name="Shape 4"/>
-          <p:cNvSpPr/>
-          <p:nvPr/>
-        </p:nvSpPr>
-        <p:spPr>
-          <a:xfrm>
-            <a:off x="2651760" y="1188720"/>
-            <a:ext cx="2926080" cy="640080"/>
+          <p:cNvPr id="6" name="Shape 3"/>
+          <p:cNvSpPr/>
+          <p:nvPr/>
+        </p:nvSpPr>
+        <p:spPr>
+          <a:xfrm>
+            <a:off x="2651760" y="685800"/>
+            <a:ext cx="2926080" cy="594360"/>
           </a:xfrm>
           <a:prstGeom prst="ellipse">
             <a:avLst/>
@@ -3783,30 +3761,30 @@
       </p:sp>
       <p:sp>
         <p:nvSpPr>
-          <p:cNvPr id="8" name="Text 5"/>
-          <p:cNvSpPr/>
-          <p:nvPr/>
-        </p:nvSpPr>
-        <p:spPr>
-          <a:xfrm>
-            <a:off x="2651760" y="1188720"/>
-            <a:ext cx="2926080" cy="640080"/>
-          </a:xfrm>
-          <a:prstGeom prst="rect">
-            <a:avLst/>
-          </a:prstGeom>
-          <a:noFill/>
-          <a:ln/>
-        </p:spPr>
-        <p:txBody>
-          <a:bodyPr wrap="square" lIns="0" tIns="0" rIns="0" bIns="0" rtlCol="0" anchor="ctr"/>
-          <a:lstStyle/>
-          <a:p>
-            <a:pPr algn="ctr" indent="0" marL="0">
-              <a:buNone/>
-            </a:pPr>
-            <a:r>
-              <a:rPr lang="en-US" sz="1600" i="1" dirty="0">
+          <p:cNvPr id="7" name="Text 4"/>
+          <p:cNvSpPr/>
+          <p:nvPr/>
+        </p:nvSpPr>
+        <p:spPr>
+          <a:xfrm>
+            <a:off x="2651760" y="685800"/>
+            <a:ext cx="2926080" cy="594360"/>
+          </a:xfrm>
+          <a:prstGeom prst="rect">
+            <a:avLst/>
+          </a:prstGeom>
+          <a:noFill/>
+          <a:ln/>
+        </p:spPr>
+        <p:txBody>
+          <a:bodyPr wrap="square" lIns="0" tIns="0" rIns="0" bIns="0" rtlCol="0" anchor="ctr"/>
+          <a:lstStyle/>
+          <a:p>
+            <a:pPr algn="ctr" indent="0" marL="0">
+              <a:buNone/>
+            </a:pPr>
+            <a:r>
+              <a:rPr lang="en-US" sz="1500" i="1" dirty="0">
                 <a:solidFill>
                   <a:srgbClr val="DAFF94"/>
                 </a:solidFill>
@@ -3816,13 +3794,13 @@
               </a:rPr>
               <a:t>TRENDS</a:t>
             </a:r>
-            <a:endParaRPr lang="en-US" sz="1600" dirty="0"/>
+            <a:endParaRPr lang="en-US" sz="1500" dirty="0"/>
           </a:p>
         </p:txBody>
       </p:sp>
       <p:pic>
         <p:nvPicPr>
-          <p:cNvPr id="9" name="Image 1" descr="/home/user/data-manipulation-exercises/.claude/skills/brand-guidelines/assets/textures/globe-lime.png">    </p:cNvPr>
+          <p:cNvPr id="8" name="Image 1" descr="/home/user/data-manipulation-exercises/.claude/skills/brand-guidelines/assets/textures/globe-lime.png">    </p:cNvPr>
           <p:cNvPicPr>
             <a:picLocks noChangeAspect="1"/>
           </p:cNvPicPr>
@@ -3836,8 +3814,8 @@
         </p:blipFill>
         <p:spPr>
           <a:xfrm>
-            <a:off x="5389656" y="1374343"/>
-            <a:ext cx="268834" cy="268834"/>
+            <a:off x="5403098" y="858164"/>
+            <a:ext cx="249631" cy="249631"/>
           </a:xfrm>
           <a:prstGeom prst="rect">
             <a:avLst/>
@@ -3846,30 +3824,30 @@
       </p:pic>
       <p:sp>
         <p:nvSpPr>
-          <p:cNvPr id="10" name="Text 6"/>
-          <p:cNvSpPr/>
-          <p:nvPr/>
-        </p:nvSpPr>
-        <p:spPr>
-          <a:xfrm>
-            <a:off x="640080" y="2194560"/>
-            <a:ext cx="6949440" cy="2377440"/>
-          </a:xfrm>
-          <a:prstGeom prst="rect">
-            <a:avLst/>
-          </a:prstGeom>
-          <a:noFill/>
-          <a:ln/>
-        </p:spPr>
-        <p:txBody>
-          <a:bodyPr wrap="square" lIns="0" tIns="0" rIns="0" bIns="0" rtlCol="0" anchor="ctr"/>
+          <p:cNvPr id="9" name="Text 5"/>
+          <p:cNvSpPr/>
+          <p:nvPr/>
+        </p:nvSpPr>
+        <p:spPr>
+          <a:xfrm>
+            <a:off x="640080" y="1371600"/>
+            <a:ext cx="6949440" cy="1097280"/>
+          </a:xfrm>
+          <a:prstGeom prst="rect">
+            <a:avLst/>
+          </a:prstGeom>
+          <a:noFill/>
+          <a:ln/>
+        </p:spPr>
+        <p:txBody>
+          <a:bodyPr wrap="square" lIns="0" tIns="0" rIns="0" bIns="0" rtlCol="0" anchor="t"/>
           <a:lstStyle/>
           <a:p>
             <a:pPr algn="l" indent="0" marL="0">
               <a:buNone/>
             </a:pPr>
             <a:r>
-              <a:rPr lang="en-US" sz="4000" b="1" i="1" dirty="0">
+              <a:rPr lang="en-US" sz="3000" b="1" i="1" dirty="0">
                 <a:solidFill>
                   <a:srgbClr val="DAFF94"/>
                 </a:solidFill>
@@ -3879,14 +3857,14 @@
               </a:rPr>
               <a:t>HIPER-</a:t>
             </a:r>
-            <a:endParaRPr lang="en-US" sz="4000" dirty="0"/>
+            <a:endParaRPr lang="en-US" sz="3000" dirty="0"/>
           </a:p>
           <a:p>
             <a:pPr algn="l" indent="0" marL="0">
               <a:buNone/>
             </a:pPr>
             <a:r>
-              <a:rPr lang="en-US" sz="4000" b="1" i="1" dirty="0">
+              <a:rPr lang="en-US" sz="3000" b="1" i="1" dirty="0">
                 <a:solidFill>
                   <a:srgbClr val="DAFF94"/>
                 </a:solidFill>
@@ -3896,44 +3874,20 @@
               </a:rPr>
               <a:t>REALIDADE</a:t>
             </a:r>
-            <a:endParaRPr lang="en-US" sz="4000" dirty="0"/>
-          </a:p>
-        </p:txBody>
-      </p:sp>
-      <p:sp>
-        <p:nvSpPr>
-          <p:cNvPr id="11" name="Shape 7"/>
-          <p:cNvSpPr/>
-          <p:nvPr/>
-        </p:nvSpPr>
-        <p:spPr>
-          <a:xfrm>
-            <a:off x="640080" y="4937760"/>
-            <a:ext cx="6949440" cy="3108960"/>
-          </a:xfrm>
-          <a:prstGeom prst="roundRect">
-            <a:avLst>
-              <a:gd name="adj" fmla="val 4412"/>
-            </a:avLst>
-          </a:prstGeom>
-          <a:solidFill>
-            <a:srgbClr val="000000">
-              <a:alpha val="78000"/>
-            </a:srgbClr>
-          </a:solidFill>
-          <a:ln/>
-        </p:spPr>
-      </p:sp>
-      <p:sp>
-        <p:nvSpPr>
-          <p:cNvPr id="12" name="Text 8"/>
-          <p:cNvSpPr/>
-          <p:nvPr/>
-        </p:nvSpPr>
-        <p:spPr>
-          <a:xfrm>
-            <a:off x="914400" y="5212080"/>
-            <a:ext cx="6400800" cy="1554480"/>
+            <a:endParaRPr lang="en-US" sz="3000" dirty="0"/>
+          </a:p>
+        </p:txBody>
+      </p:sp>
+      <p:sp>
+        <p:nvSpPr>
+          <p:cNvPr id="10" name="Text 6"/>
+          <p:cNvSpPr/>
+          <p:nvPr/>
+        </p:nvSpPr>
+        <p:spPr>
+          <a:xfrm>
+            <a:off x="640080" y="2606040"/>
+            <a:ext cx="6949440" cy="822960"/>
           </a:xfrm>
           <a:prstGeom prst="rect">
             <a:avLst/>
@@ -3949,7 +3903,7 @@
               <a:buNone/>
             </a:pPr>
             <a:r>
-              <a:rPr lang="en-US" sz="2200" b="1" dirty="0">
+              <a:rPr lang="en-US" sz="1500" b="1" dirty="0">
                 <a:solidFill>
                   <a:srgbClr val="DAFF94"/>
                 </a:solidFill>
@@ -3959,20 +3913,20 @@
               </a:rPr>
               <a:t>Online ou offline? Pra Geração Z, já não faz diferença.</a:t>
             </a:r>
-            <a:endParaRPr lang="en-US" sz="2200" dirty="0"/>
-          </a:p>
-        </p:txBody>
-      </p:sp>
-      <p:sp>
-        <p:nvSpPr>
-          <p:cNvPr id="13" name="Text 9"/>
-          <p:cNvSpPr/>
-          <p:nvPr/>
-        </p:nvSpPr>
-        <p:spPr>
-          <a:xfrm>
-            <a:off x="914400" y="6858000"/>
-            <a:ext cx="6400800" cy="1005840"/>
+            <a:endParaRPr lang="en-US" sz="1500" dirty="0"/>
+          </a:p>
+        </p:txBody>
+      </p:sp>
+      <p:sp>
+        <p:nvSpPr>
+          <p:cNvPr id="11" name="Text 7"/>
+          <p:cNvSpPr/>
+          <p:nvPr/>
+        </p:nvSpPr>
+        <p:spPr>
+          <a:xfrm>
+            <a:off x="640080" y="3566160"/>
+            <a:ext cx="6492240" cy="594360"/>
           </a:xfrm>
           <a:prstGeom prst="rect">
             <a:avLst/>
@@ -3988,7 +3942,7 @@
               <a:buNone/>
             </a:pPr>
             <a:r>
-              <a:rPr lang="en-US" sz="1300" dirty="0">
+              <a:rPr lang="en-US" sz="1000" dirty="0">
                 <a:solidFill>
                   <a:srgbClr val="DAFF94"/>
                 </a:solidFill>
@@ -3998,20 +3952,20 @@
               </a:rPr>
               <a:t>40% dos jovens dizem que “é tudo real”, sem diferenciar o virtual do físico.</a:t>
             </a:r>
-            <a:endParaRPr lang="en-US" sz="1300" dirty="0"/>
-          </a:p>
-        </p:txBody>
-      </p:sp>
-      <p:sp>
-        <p:nvSpPr>
-          <p:cNvPr id="14" name="Text 10"/>
-          <p:cNvSpPr/>
-          <p:nvPr/>
-        </p:nvSpPr>
-        <p:spPr>
-          <a:xfrm>
-            <a:off x="640080" y="9646920"/>
-            <a:ext cx="1828800" cy="365760"/>
+            <a:endParaRPr lang="en-US" sz="1000" dirty="0"/>
+          </a:p>
+        </p:txBody>
+      </p:sp>
+      <p:sp>
+        <p:nvSpPr>
+          <p:cNvPr id="12" name="Text 8"/>
+          <p:cNvSpPr/>
+          <p:nvPr/>
+        </p:nvSpPr>
+        <p:spPr>
+          <a:xfrm>
+            <a:off x="640080" y="4343400"/>
+            <a:ext cx="1828800" cy="320040"/>
           </a:xfrm>
           <a:prstGeom prst="rect">
             <a:avLst/>
@@ -4027,7 +3981,7 @@
               <a:buNone/>
             </a:pPr>
             <a:r>
-              <a:rPr lang="en-US" sz="1100" dirty="0">
+              <a:rPr lang="en-US" sz="1000" dirty="0">
                 <a:solidFill>
                   <a:srgbClr val="DAFF94"/>
                 </a:solidFill>
@@ -4037,13 +3991,13 @@
               </a:rPr>
               <a:t>1 / 5</a:t>
             </a:r>
-            <a:endParaRPr lang="en-US" sz="1100" dirty="0"/>
+            <a:endParaRPr lang="en-US" sz="1000" dirty="0"/>
           </a:p>
         </p:txBody>
       </p:sp>
       <p:pic>
         <p:nvPicPr>
-          <p:cNvPr id="15" name="Image 2" descr="/home/user/data-manipulation-exercises/.claude/skills/brand-guidelines/assets/textures/arrow-lime.png">    </p:cNvPr>
+          <p:cNvPr id="13" name="Image 2" descr="/home/user/data-manipulation-exercises/.claude/skills/brand-guidelines/assets/textures/arrow-lime.png">    </p:cNvPr>
           <p:cNvPicPr>
             <a:picLocks noChangeAspect="1"/>
           </p:cNvPicPr>
@@ -4057,7 +4011,7 @@
         </p:blipFill>
         <p:spPr>
           <a:xfrm rot="5400000">
-            <a:off x="7223760" y="9281160"/>
+            <a:off x="7223760" y="4279392"/>
             <a:ext cx="292608" cy="292608"/>
           </a:xfrm>
           <a:prstGeom prst="rect">
@@ -4357,27 +4311,42 @@
       </p:sp>
       <p:sp>
         <p:nvSpPr>
-          <p:cNvPr id="9" name="Shape 6"/>
-          <p:cNvSpPr/>
-          <p:nvPr/>
-        </p:nvSpPr>
-        <p:spPr>
-          <a:xfrm>
-            <a:off x="640080" y="4937760"/>
-            <a:ext cx="6949440" cy="3108960"/>
-          </a:xfrm>
-          <a:prstGeom prst="roundRect">
-            <a:avLst>
-              <a:gd name="adj" fmla="val 4412"/>
-            </a:avLst>
-          </a:prstGeom>
-          <a:solidFill>
-            <a:srgbClr val="FFFFFF">
-              <a:alpha val="45000"/>
-            </a:srgbClr>
-          </a:solidFill>
-          <a:ln/>
-        </p:spPr>
+          <p:cNvPr id="9" name="Text 6"/>
+          <p:cNvSpPr/>
+          <p:nvPr/>
+        </p:nvSpPr>
+        <p:spPr>
+          <a:xfrm>
+            <a:off x="914400" y="4937760"/>
+            <a:ext cx="6400800" cy="1554480"/>
+          </a:xfrm>
+          <a:prstGeom prst="rect">
+            <a:avLst/>
+          </a:prstGeom>
+          <a:noFill/>
+          <a:ln/>
+        </p:spPr>
+        <p:txBody>
+          <a:bodyPr wrap="square" lIns="0" tIns="0" rIns="0" bIns="0" rtlCol="0" anchor="t"/>
+          <a:lstStyle/>
+          <a:p>
+            <a:pPr algn="l" indent="0" marL="0">
+              <a:buNone/>
+            </a:pPr>
+            <a:r>
+              <a:rPr lang="en-US" sz="2200" b="1" dirty="0">
+                <a:solidFill>
+                  <a:srgbClr val="000000"/>
+                </a:solidFill>
+                <a:latin typeface="Arial" pitchFamily="34" charset="0"/>
+                <a:ea typeface="Arial" pitchFamily="34" charset="-122"/>
+                <a:cs typeface="Arial" pitchFamily="34" charset="-120"/>
+              </a:rPr>
+              <a:t>Sua marca já apareceu numa resposta de IA hoje?</a:t>
+            </a:r>
+            <a:endParaRPr lang="en-US" sz="2200" dirty="0"/>
+          </a:p>
+        </p:txBody>
       </p:sp>
       <p:sp>
         <p:nvSpPr>
@@ -4387,46 +4356,7 @@
         </p:nvSpPr>
         <p:spPr>
           <a:xfrm>
-            <a:off x="914400" y="5212080"/>
-            <a:ext cx="6400800" cy="1554480"/>
-          </a:xfrm>
-          <a:prstGeom prst="rect">
-            <a:avLst/>
-          </a:prstGeom>
-          <a:noFill/>
-          <a:ln/>
-        </p:spPr>
-        <p:txBody>
-          <a:bodyPr wrap="square" lIns="0" tIns="0" rIns="0" bIns="0" rtlCol="0" anchor="t"/>
-          <a:lstStyle/>
-          <a:p>
-            <a:pPr algn="l" indent="0" marL="0">
-              <a:buNone/>
-            </a:pPr>
-            <a:r>
-              <a:rPr lang="en-US" sz="2200" b="1" dirty="0">
-                <a:solidFill>
-                  <a:srgbClr val="000000"/>
-                </a:solidFill>
-                <a:latin typeface="Arial" pitchFamily="34" charset="0"/>
-                <a:ea typeface="Arial" pitchFamily="34" charset="-122"/>
-                <a:cs typeface="Arial" pitchFamily="34" charset="-120"/>
-              </a:rPr>
-              <a:t>Sua marca já apareceu numa resposta de IA hoje?</a:t>
-            </a:r>
-            <a:endParaRPr lang="en-US" sz="2200" dirty="0"/>
-          </a:p>
-        </p:txBody>
-      </p:sp>
-      <p:sp>
-        <p:nvSpPr>
-          <p:cNvPr id="11" name="Text 8"/>
-          <p:cNvSpPr/>
-          <p:nvPr/>
-        </p:nvSpPr>
-        <p:spPr>
-          <a:xfrm>
-            <a:off x="914400" y="6858000"/>
+            <a:off x="914400" y="6583680"/>
             <a:ext cx="6400800" cy="1005840"/>
           </a:xfrm>
           <a:prstGeom prst="rect">
@@ -4459,7 +4389,7 @@
       </p:sp>
       <p:sp>
         <p:nvSpPr>
-          <p:cNvPr id="12" name="Text 9"/>
+          <p:cNvPr id="11" name="Text 8"/>
           <p:cNvSpPr/>
           <p:nvPr/>
         </p:nvSpPr>
@@ -4498,7 +4428,7 @@
       </p:sp>
       <p:pic>
         <p:nvPicPr>
-          <p:cNvPr id="13" name="Image 1" descr="/home/user/data-manipulation-exercises/.claude/skills/brand-guidelines/assets/textures/arrow-black.png">    </p:cNvPr>
+          <p:cNvPr id="12" name="Image 1" descr="/home/user/data-manipulation-exercises/.claude/skills/brand-guidelines/assets/textures/arrow-black.png">    </p:cNvPr>
           <p:cNvPicPr>
             <a:picLocks noChangeAspect="1"/>
           </p:cNvPicPr>
@@ -4567,8 +4497,8 @@
         </p:blipFill>
         <p:spPr>
           <a:xfrm>
-            <a:off x="0" y="0"/>
-            <a:ext cx="8229600" cy="10287000"/>
+            <a:off x="0" y="4937760"/>
+            <a:ext cx="8229600" cy="5349240"/>
           </a:xfrm>
           <a:prstGeom prst="rect">
             <a:avLst/>
@@ -4577,29 +4507,7 @@
       </p:pic>
       <p:sp>
         <p:nvSpPr>
-          <p:cNvPr id="3" name="Shape 0"/>
-          <p:cNvSpPr/>
-          <p:nvPr/>
-        </p:nvSpPr>
-        <p:spPr>
-          <a:xfrm>
-            <a:off x="0" y="0"/>
-            <a:ext cx="8229600" cy="4937760"/>
-          </a:xfrm>
-          <a:prstGeom prst="rect">
-            <a:avLst/>
-          </a:prstGeom>
-          <a:solidFill>
-            <a:srgbClr val="000000">
-              <a:alpha val="68000"/>
-            </a:srgbClr>
-          </a:solidFill>
-          <a:ln/>
-        </p:spPr>
-      </p:sp>
-      <p:sp>
-        <p:nvSpPr>
-          <p:cNvPr id="4" name="Text 1"/>
+          <p:cNvPr id="3" name="Text 0"/>
           <p:cNvSpPr/>
           <p:nvPr/>
         </p:nvSpPr>
@@ -4638,7 +4546,7 @@
       </p:sp>
       <p:sp>
         <p:nvSpPr>
-          <p:cNvPr id="5" name="Text 2"/>
+          <p:cNvPr id="4" name="Text 1"/>
           <p:cNvSpPr/>
           <p:nvPr/>
         </p:nvSpPr>
@@ -4677,7 +4585,7 @@
       </p:sp>
       <p:sp>
         <p:nvSpPr>
-          <p:cNvPr id="6" name="Text 3"/>
+          <p:cNvPr id="5" name="Text 2"/>
           <p:cNvSpPr/>
           <p:nvPr/>
         </p:nvSpPr>
@@ -4716,14 +4624,14 @@
       </p:sp>
       <p:sp>
         <p:nvSpPr>
-          <p:cNvPr id="7" name="Shape 4"/>
-          <p:cNvSpPr/>
-          <p:nvPr/>
-        </p:nvSpPr>
-        <p:spPr>
-          <a:xfrm>
-            <a:off x="2651760" y="1188720"/>
-            <a:ext cx="2926080" cy="640080"/>
+          <p:cNvPr id="6" name="Shape 3"/>
+          <p:cNvSpPr/>
+          <p:nvPr/>
+        </p:nvSpPr>
+        <p:spPr>
+          <a:xfrm>
+            <a:off x="2651760" y="685800"/>
+            <a:ext cx="2926080" cy="594360"/>
           </a:xfrm>
           <a:prstGeom prst="ellipse">
             <a:avLst/>
@@ -4738,30 +4646,30 @@
       </p:sp>
       <p:sp>
         <p:nvSpPr>
-          <p:cNvPr id="8" name="Text 5"/>
-          <p:cNvSpPr/>
-          <p:nvPr/>
-        </p:nvSpPr>
-        <p:spPr>
-          <a:xfrm>
-            <a:off x="2651760" y="1188720"/>
-            <a:ext cx="2926080" cy="640080"/>
-          </a:xfrm>
-          <a:prstGeom prst="rect">
-            <a:avLst/>
-          </a:prstGeom>
-          <a:noFill/>
-          <a:ln/>
-        </p:spPr>
-        <p:txBody>
-          <a:bodyPr wrap="square" lIns="0" tIns="0" rIns="0" bIns="0" rtlCol="0" anchor="ctr"/>
-          <a:lstStyle/>
-          <a:p>
-            <a:pPr algn="ctr" indent="0" marL="0">
-              <a:buNone/>
-            </a:pPr>
-            <a:r>
-              <a:rPr lang="en-US" sz="1600" i="1" dirty="0">
+          <p:cNvPr id="7" name="Text 4"/>
+          <p:cNvSpPr/>
+          <p:nvPr/>
+        </p:nvSpPr>
+        <p:spPr>
+          <a:xfrm>
+            <a:off x="2651760" y="685800"/>
+            <a:ext cx="2926080" cy="594360"/>
+          </a:xfrm>
+          <a:prstGeom prst="rect">
+            <a:avLst/>
+          </a:prstGeom>
+          <a:noFill/>
+          <a:ln/>
+        </p:spPr>
+        <p:txBody>
+          <a:bodyPr wrap="square" lIns="0" tIns="0" rIns="0" bIns="0" rtlCol="0" anchor="ctr"/>
+          <a:lstStyle/>
+          <a:p>
+            <a:pPr algn="ctr" indent="0" marL="0">
+              <a:buNone/>
+            </a:pPr>
+            <a:r>
+              <a:rPr lang="en-US" sz="1500" i="1" dirty="0">
                 <a:solidFill>
                   <a:srgbClr val="000000"/>
                 </a:solidFill>
@@ -4771,13 +4679,13 @@
               </a:rPr>
               <a:t>TRENDS</a:t>
             </a:r>
-            <a:endParaRPr lang="en-US" sz="1600" dirty="0"/>
+            <a:endParaRPr lang="en-US" sz="1500" dirty="0"/>
           </a:p>
         </p:txBody>
       </p:sp>
       <p:pic>
         <p:nvPicPr>
-          <p:cNvPr id="9" name="Image 1" descr="/home/user/data-manipulation-exercises/.claude/skills/brand-guidelines/assets/textures/globe-lime.png">    </p:cNvPr>
+          <p:cNvPr id="8" name="Image 1" descr="/home/user/data-manipulation-exercises/.claude/skills/brand-guidelines/assets/textures/globe-lime.png">    </p:cNvPr>
           <p:cNvPicPr>
             <a:picLocks noChangeAspect="1"/>
           </p:cNvPicPr>
@@ -4791,8 +4699,8 @@
         </p:blipFill>
         <p:spPr>
           <a:xfrm>
-            <a:off x="5389656" y="1374343"/>
-            <a:ext cx="268834" cy="268834"/>
+            <a:off x="5403098" y="858164"/>
+            <a:ext cx="249631" cy="249631"/>
           </a:xfrm>
           <a:prstGeom prst="rect">
             <a:avLst/>
@@ -4801,30 +4709,30 @@
       </p:pic>
       <p:sp>
         <p:nvSpPr>
-          <p:cNvPr id="10" name="Text 6"/>
-          <p:cNvSpPr/>
-          <p:nvPr/>
-        </p:nvSpPr>
-        <p:spPr>
-          <a:xfrm>
-            <a:off x="640080" y="2194560"/>
-            <a:ext cx="6949440" cy="2377440"/>
-          </a:xfrm>
-          <a:prstGeom prst="rect">
-            <a:avLst/>
-          </a:prstGeom>
-          <a:noFill/>
-          <a:ln/>
-        </p:spPr>
-        <p:txBody>
-          <a:bodyPr wrap="square" lIns="0" tIns="0" rIns="0" bIns="0" rtlCol="0" anchor="ctr"/>
+          <p:cNvPr id="9" name="Text 5"/>
+          <p:cNvSpPr/>
+          <p:nvPr/>
+        </p:nvSpPr>
+        <p:spPr>
+          <a:xfrm>
+            <a:off x="640080" y="1371600"/>
+            <a:ext cx="6949440" cy="1097280"/>
+          </a:xfrm>
+          <a:prstGeom prst="rect">
+            <a:avLst/>
+          </a:prstGeom>
+          <a:noFill/>
+          <a:ln/>
+        </p:spPr>
+        <p:txBody>
+          <a:bodyPr wrap="square" lIns="0" tIns="0" rIns="0" bIns="0" rtlCol="0" anchor="t"/>
           <a:lstStyle/>
           <a:p>
             <a:pPr algn="l" indent="0" marL="0">
               <a:buNone/>
             </a:pPr>
             <a:r>
-              <a:rPr lang="en-US" sz="4000" b="1" i="1" dirty="0">
+              <a:rPr lang="en-US" sz="3000" b="1" i="1" dirty="0">
                 <a:solidFill>
                   <a:srgbClr val="000000"/>
                 </a:solidFill>
@@ -4834,14 +4742,14 @@
               </a:rPr>
               <a:t>GERAÇÃO</a:t>
             </a:r>
-            <a:endParaRPr lang="en-US" sz="4000" dirty="0"/>
+            <a:endParaRPr lang="en-US" sz="3000" dirty="0"/>
           </a:p>
           <a:p>
             <a:pPr algn="l" indent="0" marL="0">
               <a:buNone/>
             </a:pPr>
             <a:r>
-              <a:rPr lang="en-US" sz="4000" b="1" i="1" dirty="0">
+              <a:rPr lang="en-US" sz="3000" b="1" i="1" dirty="0">
                 <a:solidFill>
                   <a:srgbClr val="000000"/>
                 </a:solidFill>
@@ -4851,44 +4759,20 @@
               </a:rPr>
               <a:t>SEM RESSACA</a:t>
             </a:r>
-            <a:endParaRPr lang="en-US" sz="4000" dirty="0"/>
-          </a:p>
-        </p:txBody>
-      </p:sp>
-      <p:sp>
-        <p:nvSpPr>
-          <p:cNvPr id="11" name="Shape 7"/>
-          <p:cNvSpPr/>
-          <p:nvPr/>
-        </p:nvSpPr>
-        <p:spPr>
-          <a:xfrm>
-            <a:off x="640080" y="4937760"/>
-            <a:ext cx="6949440" cy="3108960"/>
-          </a:xfrm>
-          <a:prstGeom prst="roundRect">
-            <a:avLst>
-              <a:gd name="adj" fmla="val 4412"/>
-            </a:avLst>
-          </a:prstGeom>
-          <a:solidFill>
-            <a:srgbClr val="000000">
-              <a:alpha val="78000"/>
-            </a:srgbClr>
-          </a:solidFill>
-          <a:ln/>
-        </p:spPr>
-      </p:sp>
-      <p:sp>
-        <p:nvSpPr>
-          <p:cNvPr id="12" name="Text 8"/>
-          <p:cNvSpPr/>
-          <p:nvPr/>
-        </p:nvSpPr>
-        <p:spPr>
-          <a:xfrm>
-            <a:off x="914400" y="5212080"/>
-            <a:ext cx="6400800" cy="1554480"/>
+            <a:endParaRPr lang="en-US" sz="3000" dirty="0"/>
+          </a:p>
+        </p:txBody>
+      </p:sp>
+      <p:sp>
+        <p:nvSpPr>
+          <p:cNvPr id="10" name="Text 6"/>
+          <p:cNvSpPr/>
+          <p:nvPr/>
+        </p:nvSpPr>
+        <p:spPr>
+          <a:xfrm>
+            <a:off x="640080" y="2606040"/>
+            <a:ext cx="6949440" cy="822960"/>
           </a:xfrm>
           <a:prstGeom prst="rect">
             <a:avLst/>
@@ -4904,7 +4788,7 @@
               <a:buNone/>
             </a:pPr>
             <a:r>
-              <a:rPr lang="en-US" sz="2200" b="1" dirty="0">
+              <a:rPr lang="en-US" sz="1500" b="1" dirty="0">
                 <a:solidFill>
                   <a:srgbClr val="000000"/>
                 </a:solidFill>
@@ -4914,20 +4798,20 @@
               </a:rPr>
               <a:t>Beber menos virou parte da experiência — não o fim dela.</a:t>
             </a:r>
-            <a:endParaRPr lang="en-US" sz="2200" dirty="0"/>
-          </a:p>
-        </p:txBody>
-      </p:sp>
-      <p:sp>
-        <p:nvSpPr>
-          <p:cNvPr id="13" name="Text 9"/>
-          <p:cNvSpPr/>
-          <p:nvPr/>
-        </p:nvSpPr>
-        <p:spPr>
-          <a:xfrm>
-            <a:off x="914400" y="6858000"/>
-            <a:ext cx="6400800" cy="1005840"/>
+            <a:endParaRPr lang="en-US" sz="1500" dirty="0"/>
+          </a:p>
+        </p:txBody>
+      </p:sp>
+      <p:sp>
+        <p:nvSpPr>
+          <p:cNvPr id="11" name="Text 7"/>
+          <p:cNvSpPr/>
+          <p:nvPr/>
+        </p:nvSpPr>
+        <p:spPr>
+          <a:xfrm>
+            <a:off x="640080" y="3566160"/>
+            <a:ext cx="6492240" cy="594360"/>
           </a:xfrm>
           <a:prstGeom prst="rect">
             <a:avLst/>
@@ -4943,7 +4827,7 @@
               <a:buNone/>
             </a:pPr>
             <a:r>
-              <a:rPr lang="en-US" sz="1300" dirty="0">
+              <a:rPr lang="en-US" sz="1000" dirty="0">
                 <a:solidFill>
                   <a:srgbClr val="000000"/>
                 </a:solidFill>
@@ -4953,20 +4837,20 @@
               </a:rPr>
               <a:t>64% dos brasileiros declararam não consumir álcool em 2025.</a:t>
             </a:r>
-            <a:endParaRPr lang="en-US" sz="1300" dirty="0"/>
-          </a:p>
-        </p:txBody>
-      </p:sp>
-      <p:sp>
-        <p:nvSpPr>
-          <p:cNvPr id="14" name="Text 10"/>
-          <p:cNvSpPr/>
-          <p:nvPr/>
-        </p:nvSpPr>
-        <p:spPr>
-          <a:xfrm>
-            <a:off x="640080" y="9646920"/>
-            <a:ext cx="1828800" cy="365760"/>
+            <a:endParaRPr lang="en-US" sz="1000" dirty="0"/>
+          </a:p>
+        </p:txBody>
+      </p:sp>
+      <p:sp>
+        <p:nvSpPr>
+          <p:cNvPr id="12" name="Text 8"/>
+          <p:cNvSpPr/>
+          <p:nvPr/>
+        </p:nvSpPr>
+        <p:spPr>
+          <a:xfrm>
+            <a:off x="640080" y="4343400"/>
+            <a:ext cx="1828800" cy="320040"/>
           </a:xfrm>
           <a:prstGeom prst="rect">
             <a:avLst/>
@@ -4982,7 +4866,7 @@
               <a:buNone/>
             </a:pPr>
             <a:r>
-              <a:rPr lang="en-US" sz="1100" dirty="0">
+              <a:rPr lang="en-US" sz="1000" dirty="0">
                 <a:solidFill>
                   <a:srgbClr val="000000"/>
                 </a:solidFill>
@@ -4992,13 +4876,13 @@
               </a:rPr>
               <a:t>3 / 5</a:t>
             </a:r>
-            <a:endParaRPr lang="en-US" sz="1100" dirty="0"/>
+            <a:endParaRPr lang="en-US" sz="1000" dirty="0"/>
           </a:p>
         </p:txBody>
       </p:sp>
       <p:pic>
         <p:nvPicPr>
-          <p:cNvPr id="15" name="Image 2" descr="/home/user/data-manipulation-exercises/.claude/skills/brand-guidelines/assets/textures/arrow-lime.png">    </p:cNvPr>
+          <p:cNvPr id="13" name="Image 2" descr="/home/user/data-manipulation-exercises/.claude/skills/brand-guidelines/assets/textures/arrow-lime.png">    </p:cNvPr>
           <p:cNvPicPr>
             <a:picLocks noChangeAspect="1"/>
           </p:cNvPicPr>
@@ -5012,7 +4896,7 @@
         </p:blipFill>
         <p:spPr>
           <a:xfrm rot="5400000">
-            <a:off x="7223760" y="9281160"/>
+            <a:off x="7223760" y="4279392"/>
             <a:ext cx="292608" cy="292608"/>
           </a:xfrm>
           <a:prstGeom prst="rect">
@@ -5068,7 +4952,7 @@
         <p:spPr>
           <a:xfrm>
             <a:off x="0" y="0"/>
-            <a:ext cx="8229600" cy="10287000"/>
+            <a:ext cx="8229600" cy="5349240"/>
           </a:xfrm>
           <a:prstGeom prst="rect">
             <a:avLst/>
@@ -5077,35 +4961,13 @@
       </p:pic>
       <p:sp>
         <p:nvSpPr>
-          <p:cNvPr id="3" name="Shape 0"/>
-          <p:cNvSpPr/>
-          <p:nvPr/>
-        </p:nvSpPr>
-        <p:spPr>
-          <a:xfrm>
-            <a:off x="0" y="0"/>
-            <a:ext cx="8229600" cy="4937760"/>
-          </a:xfrm>
-          <a:prstGeom prst="rect">
-            <a:avLst/>
-          </a:prstGeom>
-          <a:solidFill>
-            <a:srgbClr val="000000">
-              <a:alpha val="68000"/>
-            </a:srgbClr>
-          </a:solidFill>
-          <a:ln/>
-        </p:spPr>
-      </p:sp>
-      <p:sp>
-        <p:nvSpPr>
-          <p:cNvPr id="4" name="Text 1"/>
-          <p:cNvSpPr/>
-          <p:nvPr/>
-        </p:nvSpPr>
-        <p:spPr>
-          <a:xfrm>
-            <a:off x="365760" y="228600"/>
+          <p:cNvPr id="3" name="Text 0"/>
+          <p:cNvSpPr/>
+          <p:nvPr/>
+        </p:nvSpPr>
+        <p:spPr>
+          <a:xfrm>
+            <a:off x="365760" y="5577840"/>
             <a:ext cx="1828800" cy="274320"/>
           </a:xfrm>
           <a:prstGeom prst="rect">
@@ -5138,13 +5000,13 @@
       </p:sp>
       <p:sp>
         <p:nvSpPr>
-          <p:cNvPr id="5" name="Text 2"/>
-          <p:cNvSpPr/>
-          <p:nvPr/>
-        </p:nvSpPr>
-        <p:spPr>
-          <a:xfrm>
-            <a:off x="3200400" y="228600"/>
+          <p:cNvPr id="4" name="Text 1"/>
+          <p:cNvSpPr/>
+          <p:nvPr/>
+        </p:nvSpPr>
+        <p:spPr>
+          <a:xfrm>
+            <a:off x="3200400" y="5577840"/>
             <a:ext cx="1828800" cy="274320"/>
           </a:xfrm>
           <a:prstGeom prst="rect">
@@ -5177,13 +5039,13 @@
       </p:sp>
       <p:sp>
         <p:nvSpPr>
-          <p:cNvPr id="6" name="Text 3"/>
-          <p:cNvSpPr/>
-          <p:nvPr/>
-        </p:nvSpPr>
-        <p:spPr>
-          <a:xfrm>
-            <a:off x="6035040" y="228600"/>
+          <p:cNvPr id="5" name="Text 2"/>
+          <p:cNvSpPr/>
+          <p:nvPr/>
+        </p:nvSpPr>
+        <p:spPr>
+          <a:xfrm>
+            <a:off x="6035040" y="5577840"/>
             <a:ext cx="1828800" cy="274320"/>
           </a:xfrm>
           <a:prstGeom prst="rect">
@@ -5216,14 +5078,14 @@
       </p:sp>
       <p:sp>
         <p:nvSpPr>
-          <p:cNvPr id="7" name="Shape 4"/>
-          <p:cNvSpPr/>
-          <p:nvPr/>
-        </p:nvSpPr>
-        <p:spPr>
-          <a:xfrm>
-            <a:off x="2651760" y="1188720"/>
-            <a:ext cx="2926080" cy="640080"/>
+          <p:cNvPr id="6" name="Shape 3"/>
+          <p:cNvSpPr/>
+          <p:nvPr/>
+        </p:nvSpPr>
+        <p:spPr>
+          <a:xfrm>
+            <a:off x="2651760" y="6035040"/>
+            <a:ext cx="2926080" cy="594360"/>
           </a:xfrm>
           <a:prstGeom prst="ellipse">
             <a:avLst/>
@@ -5238,30 +5100,30 @@
       </p:sp>
       <p:sp>
         <p:nvSpPr>
-          <p:cNvPr id="8" name="Text 5"/>
-          <p:cNvSpPr/>
-          <p:nvPr/>
-        </p:nvSpPr>
-        <p:spPr>
-          <a:xfrm>
-            <a:off x="2651760" y="1188720"/>
-            <a:ext cx="2926080" cy="640080"/>
-          </a:xfrm>
-          <a:prstGeom prst="rect">
-            <a:avLst/>
-          </a:prstGeom>
-          <a:noFill/>
-          <a:ln/>
-        </p:spPr>
-        <p:txBody>
-          <a:bodyPr wrap="square" lIns="0" tIns="0" rIns="0" bIns="0" rtlCol="0" anchor="ctr"/>
-          <a:lstStyle/>
-          <a:p>
-            <a:pPr algn="ctr" indent="0" marL="0">
-              <a:buNone/>
-            </a:pPr>
-            <a:r>
-              <a:rPr lang="en-US" sz="1600" i="1" dirty="0">
+          <p:cNvPr id="7" name="Text 4"/>
+          <p:cNvSpPr/>
+          <p:nvPr/>
+        </p:nvSpPr>
+        <p:spPr>
+          <a:xfrm>
+            <a:off x="2651760" y="6035040"/>
+            <a:ext cx="2926080" cy="594360"/>
+          </a:xfrm>
+          <a:prstGeom prst="rect">
+            <a:avLst/>
+          </a:prstGeom>
+          <a:noFill/>
+          <a:ln/>
+        </p:spPr>
+        <p:txBody>
+          <a:bodyPr wrap="square" lIns="0" tIns="0" rIns="0" bIns="0" rtlCol="0" anchor="ctr"/>
+          <a:lstStyle/>
+          <a:p>
+            <a:pPr algn="ctr" indent="0" marL="0">
+              <a:buNone/>
+            </a:pPr>
+            <a:r>
+              <a:rPr lang="en-US" sz="1500" i="1" dirty="0">
                 <a:solidFill>
                   <a:srgbClr val="DAFF94"/>
                 </a:solidFill>
@@ -5271,13 +5133,13 @@
               </a:rPr>
               <a:t>TRENDS</a:t>
             </a:r>
-            <a:endParaRPr lang="en-US" sz="1600" dirty="0"/>
+            <a:endParaRPr lang="en-US" sz="1500" dirty="0"/>
           </a:p>
         </p:txBody>
       </p:sp>
       <p:pic>
         <p:nvPicPr>
-          <p:cNvPr id="9" name="Image 1" descr="/home/user/data-manipulation-exercises/.claude/skills/brand-guidelines/assets/textures/globe-lime.png">    </p:cNvPr>
+          <p:cNvPr id="8" name="Image 1" descr="/home/user/data-manipulation-exercises/.claude/skills/brand-guidelines/assets/textures/globe-lime.png">    </p:cNvPr>
           <p:cNvPicPr>
             <a:picLocks noChangeAspect="1"/>
           </p:cNvPicPr>
@@ -5291,8 +5153,8 @@
         </p:blipFill>
         <p:spPr>
           <a:xfrm>
-            <a:off x="5389656" y="1374343"/>
-            <a:ext cx="268834" cy="268834"/>
+            <a:off x="5403098" y="6207404"/>
+            <a:ext cx="249631" cy="249631"/>
           </a:xfrm>
           <a:prstGeom prst="rect">
             <a:avLst/>
@@ -5301,30 +5163,30 @@
       </p:pic>
       <p:sp>
         <p:nvSpPr>
-          <p:cNvPr id="10" name="Text 6"/>
-          <p:cNvSpPr/>
-          <p:nvPr/>
-        </p:nvSpPr>
-        <p:spPr>
-          <a:xfrm>
-            <a:off x="640080" y="2194560"/>
-            <a:ext cx="6949440" cy="2377440"/>
-          </a:xfrm>
-          <a:prstGeom prst="rect">
-            <a:avLst/>
-          </a:prstGeom>
-          <a:noFill/>
-          <a:ln/>
-        </p:spPr>
-        <p:txBody>
-          <a:bodyPr wrap="square" lIns="0" tIns="0" rIns="0" bIns="0" rtlCol="0" anchor="ctr"/>
+          <p:cNvPr id="9" name="Text 5"/>
+          <p:cNvSpPr/>
+          <p:nvPr/>
+        </p:nvSpPr>
+        <p:spPr>
+          <a:xfrm>
+            <a:off x="640080" y="6720840"/>
+            <a:ext cx="6949440" cy="1097280"/>
+          </a:xfrm>
+          <a:prstGeom prst="rect">
+            <a:avLst/>
+          </a:prstGeom>
+          <a:noFill/>
+          <a:ln/>
+        </p:spPr>
+        <p:txBody>
+          <a:bodyPr wrap="square" lIns="0" tIns="0" rIns="0" bIns="0" rtlCol="0" anchor="t"/>
           <a:lstStyle/>
           <a:p>
             <a:pPr algn="l" indent="0" marL="0">
               <a:buNone/>
             </a:pPr>
             <a:r>
-              <a:rPr lang="en-US" sz="4000" b="1" i="1" dirty="0">
+              <a:rPr lang="en-US" sz="3000" b="1" i="1" dirty="0">
                 <a:solidFill>
                   <a:srgbClr val="DAFF94"/>
                 </a:solidFill>
@@ -5334,14 +5196,14 @@
               </a:rPr>
               <a:t>NEW-WAVE</a:t>
             </a:r>
-            <a:endParaRPr lang="en-US" sz="4000" dirty="0"/>
+            <a:endParaRPr lang="en-US" sz="3000" dirty="0"/>
           </a:p>
           <a:p>
             <a:pPr algn="l" indent="0" marL="0">
               <a:buNone/>
             </a:pPr>
             <a:r>
-              <a:rPr lang="en-US" sz="4000" b="1" i="1" dirty="0">
+              <a:rPr lang="en-US" sz="3000" b="1" i="1" dirty="0">
                 <a:solidFill>
                   <a:srgbClr val="DAFF94"/>
                 </a:solidFill>
@@ -5351,44 +5213,20 @@
               </a:rPr>
               <a:t>SPORT FANDOM</a:t>
             </a:r>
-            <a:endParaRPr lang="en-US" sz="4000" dirty="0"/>
-          </a:p>
-        </p:txBody>
-      </p:sp>
-      <p:sp>
-        <p:nvSpPr>
-          <p:cNvPr id="11" name="Shape 7"/>
-          <p:cNvSpPr/>
-          <p:nvPr/>
-        </p:nvSpPr>
-        <p:spPr>
-          <a:xfrm>
-            <a:off x="640080" y="4937760"/>
-            <a:ext cx="6949440" cy="3108960"/>
-          </a:xfrm>
-          <a:prstGeom prst="roundRect">
-            <a:avLst>
-              <a:gd name="adj" fmla="val 4412"/>
-            </a:avLst>
-          </a:prstGeom>
-          <a:solidFill>
-            <a:srgbClr val="000000">
-              <a:alpha val="78000"/>
-            </a:srgbClr>
-          </a:solidFill>
-          <a:ln/>
-        </p:spPr>
-      </p:sp>
-      <p:sp>
-        <p:nvSpPr>
-          <p:cNvPr id="12" name="Text 8"/>
-          <p:cNvSpPr/>
-          <p:nvPr/>
-        </p:nvSpPr>
-        <p:spPr>
-          <a:xfrm>
-            <a:off x="914400" y="5212080"/>
-            <a:ext cx="6400800" cy="1554480"/>
+            <a:endParaRPr lang="en-US" sz="3000" dirty="0"/>
+          </a:p>
+        </p:txBody>
+      </p:sp>
+      <p:sp>
+        <p:nvSpPr>
+          <p:cNvPr id="10" name="Text 6"/>
+          <p:cNvSpPr/>
+          <p:nvPr/>
+        </p:nvSpPr>
+        <p:spPr>
+          <a:xfrm>
+            <a:off x="640080" y="7955280"/>
+            <a:ext cx="6949440" cy="822960"/>
           </a:xfrm>
           <a:prstGeom prst="rect">
             <a:avLst/>
@@ -5404,7 +5242,7 @@
               <a:buNone/>
             </a:pPr>
             <a:r>
-              <a:rPr lang="en-US" sz="2200" b="1" dirty="0">
+              <a:rPr lang="en-US" sz="1500" b="1" dirty="0">
                 <a:solidFill>
                   <a:srgbClr val="DAFF94"/>
                 </a:solidFill>
@@ -5414,20 +5252,20 @@
               </a:rPr>
               <a:t>O esporte tem uma nova torcida: jovem, feminina e apaixonada por estilo.</a:t>
             </a:r>
-            <a:endParaRPr lang="en-US" sz="2200" dirty="0"/>
-          </a:p>
-        </p:txBody>
-      </p:sp>
-      <p:sp>
-        <p:nvSpPr>
-          <p:cNvPr id="13" name="Text 9"/>
-          <p:cNvSpPr/>
-          <p:nvPr/>
-        </p:nvSpPr>
-        <p:spPr>
-          <a:xfrm>
-            <a:off x="914400" y="6858000"/>
-            <a:ext cx="6400800" cy="1005840"/>
+            <a:endParaRPr lang="en-US" sz="1500" dirty="0"/>
+          </a:p>
+        </p:txBody>
+      </p:sp>
+      <p:sp>
+        <p:nvSpPr>
+          <p:cNvPr id="11" name="Text 7"/>
+          <p:cNvSpPr/>
+          <p:nvPr/>
+        </p:nvSpPr>
+        <p:spPr>
+          <a:xfrm>
+            <a:off x="640080" y="8915400"/>
+            <a:ext cx="6492240" cy="594360"/>
           </a:xfrm>
           <a:prstGeom prst="rect">
             <a:avLst/>
@@ -5443,7 +5281,7 @@
               <a:buNone/>
             </a:pPr>
             <a:r>
-              <a:rPr lang="en-US" sz="1300" dirty="0">
+              <a:rPr lang="en-US" sz="1000" dirty="0">
                 <a:solidFill>
                   <a:srgbClr val="DAFF94"/>
                 </a:solidFill>
@@ -5453,20 +5291,20 @@
               </a:rPr>
               <a:t>3 em cada 4 novos fãs de Fórmula 1 são mulheres.</a:t>
             </a:r>
-            <a:endParaRPr lang="en-US" sz="1300" dirty="0"/>
-          </a:p>
-        </p:txBody>
-      </p:sp>
-      <p:sp>
-        <p:nvSpPr>
-          <p:cNvPr id="14" name="Text 10"/>
-          <p:cNvSpPr/>
-          <p:nvPr/>
-        </p:nvSpPr>
-        <p:spPr>
-          <a:xfrm>
-            <a:off x="640080" y="9646920"/>
-            <a:ext cx="1828800" cy="365760"/>
+            <a:endParaRPr lang="en-US" sz="1000" dirty="0"/>
+          </a:p>
+        </p:txBody>
+      </p:sp>
+      <p:sp>
+        <p:nvSpPr>
+          <p:cNvPr id="12" name="Text 8"/>
+          <p:cNvSpPr/>
+          <p:nvPr/>
+        </p:nvSpPr>
+        <p:spPr>
+          <a:xfrm>
+            <a:off x="640080" y="9692640"/>
+            <a:ext cx="1828800" cy="320040"/>
           </a:xfrm>
           <a:prstGeom prst="rect">
             <a:avLst/>
@@ -5482,7 +5320,7 @@
               <a:buNone/>
             </a:pPr>
             <a:r>
-              <a:rPr lang="en-US" sz="1100" dirty="0">
+              <a:rPr lang="en-US" sz="1000" dirty="0">
                 <a:solidFill>
                   <a:srgbClr val="DAFF94"/>
                 </a:solidFill>
@@ -5492,13 +5330,13 @@
               </a:rPr>
               <a:t>4 / 5</a:t>
             </a:r>
-            <a:endParaRPr lang="en-US" sz="1100" dirty="0"/>
+            <a:endParaRPr lang="en-US" sz="1000" dirty="0"/>
           </a:p>
         </p:txBody>
       </p:sp>
       <p:pic>
         <p:nvPicPr>
-          <p:cNvPr id="15" name="Image 2" descr="/home/user/data-manipulation-exercises/.claude/skills/brand-guidelines/assets/textures/arrow-lime.png">    </p:cNvPr>
+          <p:cNvPr id="13" name="Image 2" descr="/home/user/data-manipulation-exercises/.claude/skills/brand-guidelines/assets/textures/arrow-lime.png">    </p:cNvPr>
           <p:cNvPicPr>
             <a:picLocks noChangeAspect="1"/>
           </p:cNvPicPr>
@@ -5512,7 +5350,7 @@
         </p:blipFill>
         <p:spPr>
           <a:xfrm rot="5400000">
-            <a:off x="7223760" y="9281160"/>
+            <a:off x="7223760" y="9628632"/>
             <a:ext cx="292608" cy="292608"/>
           </a:xfrm>
           <a:prstGeom prst="rect">
@@ -5567,8 +5405,8 @@
         </p:blipFill>
         <p:spPr>
           <a:xfrm>
-            <a:off x="0" y="0"/>
-            <a:ext cx="8229600" cy="10287000"/>
+            <a:off x="0" y="4937760"/>
+            <a:ext cx="8229600" cy="5349240"/>
           </a:xfrm>
           <a:prstGeom prst="rect">
             <a:avLst/>
@@ -5577,29 +5415,7 @@
       </p:pic>
       <p:sp>
         <p:nvSpPr>
-          <p:cNvPr id="3" name="Shape 0"/>
-          <p:cNvSpPr/>
-          <p:nvPr/>
-        </p:nvSpPr>
-        <p:spPr>
-          <a:xfrm>
-            <a:off x="0" y="0"/>
-            <a:ext cx="8229600" cy="4937760"/>
-          </a:xfrm>
-          <a:prstGeom prst="rect">
-            <a:avLst/>
-          </a:prstGeom>
-          <a:solidFill>
-            <a:srgbClr val="000000">
-              <a:alpha val="68000"/>
-            </a:srgbClr>
-          </a:solidFill>
-          <a:ln/>
-        </p:spPr>
-      </p:sp>
-      <p:sp>
-        <p:nvSpPr>
-          <p:cNvPr id="4" name="Text 1"/>
+          <p:cNvPr id="3" name="Text 0"/>
           <p:cNvSpPr/>
           <p:nvPr/>
         </p:nvSpPr>
@@ -5638,7 +5454,7 @@
       </p:sp>
       <p:sp>
         <p:nvSpPr>
-          <p:cNvPr id="5" name="Text 2"/>
+          <p:cNvPr id="4" name="Text 1"/>
           <p:cNvSpPr/>
           <p:nvPr/>
         </p:nvSpPr>
@@ -5677,7 +5493,7 @@
       </p:sp>
       <p:sp>
         <p:nvSpPr>
-          <p:cNvPr id="6" name="Text 3"/>
+          <p:cNvPr id="5" name="Text 2"/>
           <p:cNvSpPr/>
           <p:nvPr/>
         </p:nvSpPr>
@@ -5716,14 +5532,14 @@
       </p:sp>
       <p:sp>
         <p:nvSpPr>
-          <p:cNvPr id="7" name="Shape 4"/>
-          <p:cNvSpPr/>
-          <p:nvPr/>
-        </p:nvSpPr>
-        <p:spPr>
-          <a:xfrm>
-            <a:off x="2651760" y="1188720"/>
-            <a:ext cx="2926080" cy="640080"/>
+          <p:cNvPr id="6" name="Shape 3"/>
+          <p:cNvSpPr/>
+          <p:nvPr/>
+        </p:nvSpPr>
+        <p:spPr>
+          <a:xfrm>
+            <a:off x="2651760" y="685800"/>
+            <a:ext cx="2926080" cy="594360"/>
           </a:xfrm>
           <a:prstGeom prst="ellipse">
             <a:avLst/>
@@ -5738,30 +5554,30 @@
       </p:sp>
       <p:sp>
         <p:nvSpPr>
-          <p:cNvPr id="8" name="Text 5"/>
-          <p:cNvSpPr/>
-          <p:nvPr/>
-        </p:nvSpPr>
-        <p:spPr>
-          <a:xfrm>
-            <a:off x="2651760" y="1188720"/>
-            <a:ext cx="2926080" cy="640080"/>
-          </a:xfrm>
-          <a:prstGeom prst="rect">
-            <a:avLst/>
-          </a:prstGeom>
-          <a:noFill/>
-          <a:ln/>
-        </p:spPr>
-        <p:txBody>
-          <a:bodyPr wrap="square" lIns="0" tIns="0" rIns="0" bIns="0" rtlCol="0" anchor="ctr"/>
-          <a:lstStyle/>
-          <a:p>
-            <a:pPr algn="ctr" indent="0" marL="0">
-              <a:buNone/>
-            </a:pPr>
-            <a:r>
-              <a:rPr lang="en-US" sz="1600" i="1" dirty="0">
+          <p:cNvPr id="7" name="Text 4"/>
+          <p:cNvSpPr/>
+          <p:nvPr/>
+        </p:nvSpPr>
+        <p:spPr>
+          <a:xfrm>
+            <a:off x="2651760" y="685800"/>
+            <a:ext cx="2926080" cy="594360"/>
+          </a:xfrm>
+          <a:prstGeom prst="rect">
+            <a:avLst/>
+          </a:prstGeom>
+          <a:noFill/>
+          <a:ln/>
+        </p:spPr>
+        <p:txBody>
+          <a:bodyPr wrap="square" lIns="0" tIns="0" rIns="0" bIns="0" rtlCol="0" anchor="ctr"/>
+          <a:lstStyle/>
+          <a:p>
+            <a:pPr algn="ctr" indent="0" marL="0">
+              <a:buNone/>
+            </a:pPr>
+            <a:r>
+              <a:rPr lang="en-US" sz="1500" i="1" dirty="0">
                 <a:solidFill>
                   <a:srgbClr val="DAFF94"/>
                 </a:solidFill>
@@ -5771,13 +5587,13 @@
               </a:rPr>
               <a:t>TRENDS</a:t>
             </a:r>
-            <a:endParaRPr lang="en-US" sz="1600" dirty="0"/>
+            <a:endParaRPr lang="en-US" sz="1500" dirty="0"/>
           </a:p>
         </p:txBody>
       </p:sp>
       <p:pic>
         <p:nvPicPr>
-          <p:cNvPr id="9" name="Image 1" descr="/home/user/data-manipulation-exercises/.claude/skills/brand-guidelines/assets/textures/globe-lime.png">    </p:cNvPr>
+          <p:cNvPr id="8" name="Image 1" descr="/home/user/data-manipulation-exercises/.claude/skills/brand-guidelines/assets/textures/globe-lime.png">    </p:cNvPr>
           <p:cNvPicPr>
             <a:picLocks noChangeAspect="1"/>
           </p:cNvPicPr>
@@ -5791,8 +5607,8 @@
         </p:blipFill>
         <p:spPr>
           <a:xfrm>
-            <a:off x="5389656" y="1374343"/>
-            <a:ext cx="268834" cy="268834"/>
+            <a:off x="5403098" y="858164"/>
+            <a:ext cx="249631" cy="249631"/>
           </a:xfrm>
           <a:prstGeom prst="rect">
             <a:avLst/>
@@ -5801,30 +5617,30 @@
       </p:pic>
       <p:sp>
         <p:nvSpPr>
-          <p:cNvPr id="10" name="Text 6"/>
-          <p:cNvSpPr/>
-          <p:nvPr/>
-        </p:nvSpPr>
-        <p:spPr>
-          <a:xfrm>
-            <a:off x="640080" y="2194560"/>
-            <a:ext cx="6949440" cy="2377440"/>
-          </a:xfrm>
-          <a:prstGeom prst="rect">
-            <a:avLst/>
-          </a:prstGeom>
-          <a:noFill/>
-          <a:ln/>
-        </p:spPr>
-        <p:txBody>
-          <a:bodyPr wrap="square" lIns="0" tIns="0" rIns="0" bIns="0" rtlCol="0" anchor="ctr"/>
+          <p:cNvPr id="9" name="Text 5"/>
+          <p:cNvSpPr/>
+          <p:nvPr/>
+        </p:nvSpPr>
+        <p:spPr>
+          <a:xfrm>
+            <a:off x="640080" y="1371600"/>
+            <a:ext cx="6949440" cy="1097280"/>
+          </a:xfrm>
+          <a:prstGeom prst="rect">
+            <a:avLst/>
+          </a:prstGeom>
+          <a:noFill/>
+          <a:ln/>
+        </p:spPr>
+        <p:txBody>
+          <a:bodyPr wrap="square" lIns="0" tIns="0" rIns="0" bIns="0" rtlCol="0" anchor="t"/>
           <a:lstStyle/>
           <a:p>
             <a:pPr algn="l" indent="0" marL="0">
               <a:buNone/>
             </a:pPr>
             <a:r>
-              <a:rPr lang="en-US" sz="4000" b="1" i="1" dirty="0">
+              <a:rPr lang="en-US" sz="3000" b="1" i="1" dirty="0">
                 <a:solidFill>
                   <a:srgbClr val="DAFF94"/>
                 </a:solidFill>
@@ -5834,14 +5650,14 @@
               </a:rPr>
               <a:t>EXPERIÊNCIAS</a:t>
             </a:r>
-            <a:endParaRPr lang="en-US" sz="4000" dirty="0"/>
+            <a:endParaRPr lang="en-US" sz="3000" dirty="0"/>
           </a:p>
           <a:p>
             <a:pPr algn="l" indent="0" marL="0">
               <a:buNone/>
             </a:pPr>
             <a:r>
-              <a:rPr lang="en-US" sz="4000" b="1" i="1" dirty="0">
+              <a:rPr lang="en-US" sz="3000" b="1" i="1" dirty="0">
                 <a:solidFill>
                   <a:srgbClr val="DAFF94"/>
                 </a:solidFill>
@@ -5851,44 +5667,20 @@
               </a:rPr>
               <a:t>TRANSFORMADORAS</a:t>
             </a:r>
-            <a:endParaRPr lang="en-US" sz="4000" dirty="0"/>
-          </a:p>
-        </p:txBody>
-      </p:sp>
-      <p:sp>
-        <p:nvSpPr>
-          <p:cNvPr id="11" name="Shape 7"/>
-          <p:cNvSpPr/>
-          <p:nvPr/>
-        </p:nvSpPr>
-        <p:spPr>
-          <a:xfrm>
-            <a:off x="640080" y="4937760"/>
-            <a:ext cx="6949440" cy="3108960"/>
-          </a:xfrm>
-          <a:prstGeom prst="roundRect">
-            <a:avLst>
-              <a:gd name="adj" fmla="val 4412"/>
-            </a:avLst>
-          </a:prstGeom>
-          <a:solidFill>
-            <a:srgbClr val="000000">
-              <a:alpha val="78000"/>
-            </a:srgbClr>
-          </a:solidFill>
-          <a:ln/>
-        </p:spPr>
-      </p:sp>
-      <p:sp>
-        <p:nvSpPr>
-          <p:cNvPr id="12" name="Text 8"/>
-          <p:cNvSpPr/>
-          <p:nvPr/>
-        </p:nvSpPr>
-        <p:spPr>
-          <a:xfrm>
-            <a:off x="914400" y="5212080"/>
-            <a:ext cx="6400800" cy="1554480"/>
+            <a:endParaRPr lang="en-US" sz="3000" dirty="0"/>
+          </a:p>
+        </p:txBody>
+      </p:sp>
+      <p:sp>
+        <p:nvSpPr>
+          <p:cNvPr id="10" name="Text 6"/>
+          <p:cNvSpPr/>
+          <p:nvPr/>
+        </p:nvSpPr>
+        <p:spPr>
+          <a:xfrm>
+            <a:off x="640080" y="2606040"/>
+            <a:ext cx="6949440" cy="822960"/>
           </a:xfrm>
           <a:prstGeom prst="rect">
             <a:avLst/>
@@ -5904,7 +5696,7 @@
               <a:buNone/>
             </a:pPr>
             <a:r>
-              <a:rPr lang="en-US" sz="2200" b="1" dirty="0">
+              <a:rPr lang="en-US" sz="1500" b="1" dirty="0">
                 <a:solidFill>
                   <a:srgbClr val="DAFF94"/>
                 </a:solidFill>
@@ -5914,20 +5706,20 @@
               </a:rPr>
               <a:t>Marcas não vendem mais momentos. Vendem transformação.</a:t>
             </a:r>
-            <a:endParaRPr lang="en-US" sz="2200" dirty="0"/>
-          </a:p>
-        </p:txBody>
-      </p:sp>
-      <p:sp>
-        <p:nvSpPr>
-          <p:cNvPr id="13" name="Text 9"/>
-          <p:cNvSpPr/>
-          <p:nvPr/>
-        </p:nvSpPr>
-        <p:spPr>
-          <a:xfrm>
-            <a:off x="914400" y="6858000"/>
-            <a:ext cx="6400800" cy="1005840"/>
+            <a:endParaRPr lang="en-US" sz="1500" dirty="0"/>
+          </a:p>
+        </p:txBody>
+      </p:sp>
+      <p:sp>
+        <p:nvSpPr>
+          <p:cNvPr id="11" name="Text 7"/>
+          <p:cNvSpPr/>
+          <p:nvPr/>
+        </p:nvSpPr>
+        <p:spPr>
+          <a:xfrm>
+            <a:off x="640080" y="3566160"/>
+            <a:ext cx="6492240" cy="594360"/>
           </a:xfrm>
           <a:prstGeom prst="rect">
             <a:avLst/>
@@ -5943,7 +5735,7 @@
               <a:buNone/>
             </a:pPr>
             <a:r>
-              <a:rPr lang="en-US" sz="1300" dirty="0">
+              <a:rPr lang="en-US" sz="1000" dirty="0">
                 <a:solidFill>
                   <a:srgbClr val="DAFF94"/>
                 </a:solidFill>
@@ -5953,20 +5745,20 @@
               </a:rPr>
               <a:t>88% das pessoas buscam hoje vivências com propósito.</a:t>
             </a:r>
-            <a:endParaRPr lang="en-US" sz="1300" dirty="0"/>
-          </a:p>
-        </p:txBody>
-      </p:sp>
-      <p:sp>
-        <p:nvSpPr>
-          <p:cNvPr id="14" name="Text 10"/>
-          <p:cNvSpPr/>
-          <p:nvPr/>
-        </p:nvSpPr>
-        <p:spPr>
-          <a:xfrm>
-            <a:off x="640080" y="9646920"/>
-            <a:ext cx="1828800" cy="365760"/>
+            <a:endParaRPr lang="en-US" sz="1000" dirty="0"/>
+          </a:p>
+        </p:txBody>
+      </p:sp>
+      <p:sp>
+        <p:nvSpPr>
+          <p:cNvPr id="12" name="Text 8"/>
+          <p:cNvSpPr/>
+          <p:nvPr/>
+        </p:nvSpPr>
+        <p:spPr>
+          <a:xfrm>
+            <a:off x="640080" y="4343400"/>
+            <a:ext cx="1828800" cy="320040"/>
           </a:xfrm>
           <a:prstGeom prst="rect">
             <a:avLst/>
@@ -5982,7 +5774,7 @@
               <a:buNone/>
             </a:pPr>
             <a:r>
-              <a:rPr lang="en-US" sz="1100" dirty="0">
+              <a:rPr lang="en-US" sz="1000" dirty="0">
                 <a:solidFill>
                   <a:srgbClr val="DAFF94"/>
                 </a:solidFill>
@@ -5992,13 +5784,13 @@
               </a:rPr>
               <a:t>5 / 5</a:t>
             </a:r>
-            <a:endParaRPr lang="en-US" sz="1100" dirty="0"/>
+            <a:endParaRPr lang="en-US" sz="1000" dirty="0"/>
           </a:p>
         </p:txBody>
       </p:sp>
       <p:pic>
         <p:nvPicPr>
-          <p:cNvPr id="15" name="Image 2" descr="/home/user/data-manipulation-exercises/.claude/skills/brand-guidelines/assets/textures/arrow-lime.png">    </p:cNvPr>
+          <p:cNvPr id="13" name="Image 2" descr="/home/user/data-manipulation-exercises/.claude/skills/brand-guidelines/assets/textures/arrow-lime.png">    </p:cNvPr>
           <p:cNvPicPr>
             <a:picLocks noChangeAspect="1"/>
           </p:cNvPicPr>
@@ -6012,7 +5804,7 @@
         </p:blipFill>
         <p:spPr>
           <a:xfrm rot="5400000">
-            <a:off x="7223760" y="9281160"/>
+            <a:off x="7223760" y="4279392"/>
             <a:ext cx="292608" cy="292608"/>
           </a:xfrm>
           <a:prstGeom prst="rect">

</xml_diff>

<commit_message>
Add ChatGPT/agentic search photo to Instagram carousel
Bianca supplied the official ChatGPT campaign photo and authorized its
use across all materials, including the public Instagram carousel.
Cover-cropped to the card's photo zone; the Agentic Search card now
follows the same text/photo stacked layout as the other trend cards.
</commit_message>
<xml_diff>
--- a/entregas-agosto26/carrossel-instagram-agosto26.pptx
+++ b/entregas-agosto26/carrossel-instagram-agosto26.pptx
@@ -4051,15 +4051,38 @@
           <a:chExt cx="0" cy="0"/>
         </a:xfrm>
       </p:grpSpPr>
-      <p:sp>
-        <p:nvSpPr>
-          <p:cNvPr id="2" name="Text 0"/>
-          <p:cNvSpPr/>
-          <p:nvPr/>
-        </p:nvSpPr>
-        <p:spPr>
-          <a:xfrm>
-            <a:off x="365760" y="228600"/>
+      <p:pic>
+        <p:nvPicPr>
+          <p:cNvPr id="2" name="Image 0" descr="/tmp/claude-0/-home-user-data-manipulation-exercises/f19acac8-ccb4-5197-8e49-c3b6029ad477/scratchpad/report-images/final/ig-agentic-search.jpg">    </p:cNvPr>
+          <p:cNvPicPr>
+            <a:picLocks noChangeAspect="1"/>
+          </p:cNvPicPr>
+          <p:nvPr/>
+        </p:nvPicPr>
+        <p:blipFill>
+          <a:blip r:embed="rId1"/>
+          <a:srcRect l="0" r="0" t="0" b="0"/>
+          <a:stretch/>
+        </p:blipFill>
+        <p:spPr>
+          <a:xfrm>
+            <a:off x="0" y="0"/>
+            <a:ext cx="8229600" cy="5349240"/>
+          </a:xfrm>
+          <a:prstGeom prst="rect">
+            <a:avLst/>
+          </a:prstGeom>
+        </p:spPr>
+      </p:pic>
+      <p:sp>
+        <p:nvSpPr>
+          <p:cNvPr id="3" name="Text 0"/>
+          <p:cNvSpPr/>
+          <p:nvPr/>
+        </p:nvSpPr>
+        <p:spPr>
+          <a:xfrm>
+            <a:off x="365760" y="5577840"/>
             <a:ext cx="1828800" cy="274320"/>
           </a:xfrm>
           <a:prstGeom prst="rect">
@@ -4092,13 +4115,13 @@
       </p:sp>
       <p:sp>
         <p:nvSpPr>
-          <p:cNvPr id="3" name="Text 1"/>
-          <p:cNvSpPr/>
-          <p:nvPr/>
-        </p:nvSpPr>
-        <p:spPr>
-          <a:xfrm>
-            <a:off x="3200400" y="228600"/>
+          <p:cNvPr id="4" name="Text 1"/>
+          <p:cNvSpPr/>
+          <p:nvPr/>
+        </p:nvSpPr>
+        <p:spPr>
+          <a:xfrm>
+            <a:off x="3200400" y="5577840"/>
             <a:ext cx="1828800" cy="274320"/>
           </a:xfrm>
           <a:prstGeom prst="rect">
@@ -4131,13 +4154,13 @@
       </p:sp>
       <p:sp>
         <p:nvSpPr>
-          <p:cNvPr id="4" name="Text 2"/>
-          <p:cNvSpPr/>
-          <p:nvPr/>
-        </p:nvSpPr>
-        <p:spPr>
-          <a:xfrm>
-            <a:off x="6035040" y="228600"/>
+          <p:cNvPr id="5" name="Text 2"/>
+          <p:cNvSpPr/>
+          <p:nvPr/>
+        </p:nvSpPr>
+        <p:spPr>
+          <a:xfrm>
+            <a:off x="6035040" y="5577840"/>
             <a:ext cx="1828800" cy="274320"/>
           </a:xfrm>
           <a:prstGeom prst="rect">
@@ -4170,14 +4193,14 @@
       </p:sp>
       <p:sp>
         <p:nvSpPr>
-          <p:cNvPr id="5" name="Shape 3"/>
-          <p:cNvSpPr/>
-          <p:nvPr/>
-        </p:nvSpPr>
-        <p:spPr>
-          <a:xfrm>
-            <a:off x="2651760" y="1188720"/>
-            <a:ext cx="2926080" cy="640080"/>
+          <p:cNvPr id="6" name="Shape 3"/>
+          <p:cNvSpPr/>
+          <p:nvPr/>
+        </p:nvSpPr>
+        <p:spPr>
+          <a:xfrm>
+            <a:off x="2651760" y="6035040"/>
+            <a:ext cx="2926080" cy="594360"/>
           </a:xfrm>
           <a:prstGeom prst="ellipse">
             <a:avLst/>
@@ -4192,30 +4215,30 @@
       </p:sp>
       <p:sp>
         <p:nvSpPr>
-          <p:cNvPr id="6" name="Text 4"/>
-          <p:cNvSpPr/>
-          <p:nvPr/>
-        </p:nvSpPr>
-        <p:spPr>
-          <a:xfrm>
-            <a:off x="2651760" y="1188720"/>
-            <a:ext cx="2926080" cy="640080"/>
-          </a:xfrm>
-          <a:prstGeom prst="rect">
-            <a:avLst/>
-          </a:prstGeom>
-          <a:noFill/>
-          <a:ln/>
-        </p:spPr>
-        <p:txBody>
-          <a:bodyPr wrap="square" lIns="0" tIns="0" rIns="0" bIns="0" rtlCol="0" anchor="ctr"/>
-          <a:lstStyle/>
-          <a:p>
-            <a:pPr algn="ctr" indent="0" marL="0">
-              <a:buNone/>
-            </a:pPr>
-            <a:r>
-              <a:rPr lang="en-US" sz="1600" i="1" dirty="0">
+          <p:cNvPr id="7" name="Text 4"/>
+          <p:cNvSpPr/>
+          <p:nvPr/>
+        </p:nvSpPr>
+        <p:spPr>
+          <a:xfrm>
+            <a:off x="2651760" y="6035040"/>
+            <a:ext cx="2926080" cy="594360"/>
+          </a:xfrm>
+          <a:prstGeom prst="rect">
+            <a:avLst/>
+          </a:prstGeom>
+          <a:noFill/>
+          <a:ln/>
+        </p:spPr>
+        <p:txBody>
+          <a:bodyPr wrap="square" lIns="0" tIns="0" rIns="0" bIns="0" rtlCol="0" anchor="ctr"/>
+          <a:lstStyle/>
+          <a:p>
+            <a:pPr algn="ctr" indent="0" marL="0">
+              <a:buNone/>
+            </a:pPr>
+            <a:r>
+              <a:rPr lang="en-US" sz="1500" i="1" dirty="0">
                 <a:solidFill>
                   <a:srgbClr val="000000"/>
                 </a:solidFill>
@@ -4225,210 +4248,13 @@
               </a:rPr>
               <a:t>NEWS</a:t>
             </a:r>
-            <a:endParaRPr lang="en-US" sz="1600" dirty="0"/>
+            <a:endParaRPr lang="en-US" sz="1500" dirty="0"/>
           </a:p>
         </p:txBody>
       </p:sp>
       <p:pic>
         <p:nvPicPr>
-          <p:cNvPr id="7" name="Image 0" descr="/home/user/data-manipulation-exercises/.claude/skills/brand-guidelines/assets/textures/globe-black.png">    </p:cNvPr>
-          <p:cNvPicPr>
-            <a:picLocks noChangeAspect="1"/>
-          </p:cNvPicPr>
-          <p:nvPr/>
-        </p:nvPicPr>
-        <p:blipFill>
-          <a:blip r:embed="rId1"/>
-          <a:stretch>
-            <a:fillRect/>
-          </a:stretch>
-        </p:blipFill>
-        <p:spPr>
-          <a:xfrm>
-            <a:off x="5389656" y="1374343"/>
-            <a:ext cx="268834" cy="268834"/>
-          </a:xfrm>
-          <a:prstGeom prst="rect">
-            <a:avLst/>
-          </a:prstGeom>
-        </p:spPr>
-      </p:pic>
-      <p:sp>
-        <p:nvSpPr>
-          <p:cNvPr id="8" name="Text 5"/>
-          <p:cNvSpPr/>
-          <p:nvPr/>
-        </p:nvSpPr>
-        <p:spPr>
-          <a:xfrm>
-            <a:off x="640080" y="2194560"/>
-            <a:ext cx="6949440" cy="2377440"/>
-          </a:xfrm>
-          <a:prstGeom prst="rect">
-            <a:avLst/>
-          </a:prstGeom>
-          <a:noFill/>
-          <a:ln/>
-        </p:spPr>
-        <p:txBody>
-          <a:bodyPr wrap="square" lIns="0" tIns="0" rIns="0" bIns="0" rtlCol="0" anchor="ctr"/>
-          <a:lstStyle/>
-          <a:p>
-            <a:pPr algn="l" indent="0" marL="0">
-              <a:buNone/>
-            </a:pPr>
-            <a:r>
-              <a:rPr lang="en-US" sz="4000" b="1" i="1" dirty="0">
-                <a:solidFill>
-                  <a:srgbClr val="000000"/>
-                </a:solidFill>
-                <a:latin typeface="Libre Baskerville" pitchFamily="34" charset="0"/>
-                <a:ea typeface="Libre Baskerville" pitchFamily="34" charset="-122"/>
-                <a:cs typeface="Libre Baskerville" pitchFamily="34" charset="-120"/>
-              </a:rPr>
-              <a:t>AGENTIC</a:t>
-            </a:r>
-            <a:endParaRPr lang="en-US" sz="4000" dirty="0"/>
-          </a:p>
-          <a:p>
-            <a:pPr algn="l" indent="0" marL="0">
-              <a:buNone/>
-            </a:pPr>
-            <a:r>
-              <a:rPr lang="en-US" sz="4000" b="1" i="1" dirty="0">
-                <a:solidFill>
-                  <a:srgbClr val="000000"/>
-                </a:solidFill>
-                <a:latin typeface="Libre Baskerville" pitchFamily="34" charset="0"/>
-                <a:ea typeface="Libre Baskerville" pitchFamily="34" charset="-122"/>
-                <a:cs typeface="Libre Baskerville" pitchFamily="34" charset="-120"/>
-              </a:rPr>
-              <a:t>SEARCH</a:t>
-            </a:r>
-            <a:endParaRPr lang="en-US" sz="4000" dirty="0"/>
-          </a:p>
-        </p:txBody>
-      </p:sp>
-      <p:sp>
-        <p:nvSpPr>
-          <p:cNvPr id="9" name="Text 6"/>
-          <p:cNvSpPr/>
-          <p:nvPr/>
-        </p:nvSpPr>
-        <p:spPr>
-          <a:xfrm>
-            <a:off x="914400" y="4937760"/>
-            <a:ext cx="6400800" cy="1554480"/>
-          </a:xfrm>
-          <a:prstGeom prst="rect">
-            <a:avLst/>
-          </a:prstGeom>
-          <a:noFill/>
-          <a:ln/>
-        </p:spPr>
-        <p:txBody>
-          <a:bodyPr wrap="square" lIns="0" tIns="0" rIns="0" bIns="0" rtlCol="0" anchor="t"/>
-          <a:lstStyle/>
-          <a:p>
-            <a:pPr algn="l" indent="0" marL="0">
-              <a:buNone/>
-            </a:pPr>
-            <a:r>
-              <a:rPr lang="en-US" sz="2200" b="1" dirty="0">
-                <a:solidFill>
-                  <a:srgbClr val="000000"/>
-                </a:solidFill>
-                <a:latin typeface="Arial" pitchFamily="34" charset="0"/>
-                <a:ea typeface="Arial" pitchFamily="34" charset="-122"/>
-                <a:cs typeface="Arial" pitchFamily="34" charset="-120"/>
-              </a:rPr>
-              <a:t>Sua marca já apareceu numa resposta de IA hoje?</a:t>
-            </a:r>
-            <a:endParaRPr lang="en-US" sz="2200" dirty="0"/>
-          </a:p>
-        </p:txBody>
-      </p:sp>
-      <p:sp>
-        <p:nvSpPr>
-          <p:cNvPr id="10" name="Text 7"/>
-          <p:cNvSpPr/>
-          <p:nvPr/>
-        </p:nvSpPr>
-        <p:spPr>
-          <a:xfrm>
-            <a:off x="914400" y="6583680"/>
-            <a:ext cx="6400800" cy="1005840"/>
-          </a:xfrm>
-          <a:prstGeom prst="rect">
-            <a:avLst/>
-          </a:prstGeom>
-          <a:noFill/>
-          <a:ln/>
-        </p:spPr>
-        <p:txBody>
-          <a:bodyPr wrap="square" lIns="0" tIns="0" rIns="0" bIns="0" rtlCol="0" anchor="t"/>
-          <a:lstStyle/>
-          <a:p>
-            <a:pPr algn="l" indent="0" marL="0">
-              <a:buNone/>
-            </a:pPr>
-            <a:r>
-              <a:rPr lang="en-US" sz="1300" dirty="0">
-                <a:solidFill>
-                  <a:srgbClr val="000000"/>
-                </a:solidFill>
-                <a:latin typeface="JetBrains Mono" pitchFamily="34" charset="0"/>
-                <a:ea typeface="JetBrains Mono" pitchFamily="34" charset="-122"/>
-                <a:cs typeface="JetBrains Mono" pitchFamily="34" charset="-120"/>
-              </a:rPr>
-              <a:t>Buscas por IA para descobrir produtos cresceram 200% em 1 ano.</a:t>
-            </a:r>
-            <a:endParaRPr lang="en-US" sz="1300" dirty="0"/>
-          </a:p>
-        </p:txBody>
-      </p:sp>
-      <p:sp>
-        <p:nvSpPr>
-          <p:cNvPr id="11" name="Text 8"/>
-          <p:cNvSpPr/>
-          <p:nvPr/>
-        </p:nvSpPr>
-        <p:spPr>
-          <a:xfrm>
-            <a:off x="640080" y="9646920"/>
-            <a:ext cx="1828800" cy="365760"/>
-          </a:xfrm>
-          <a:prstGeom prst="rect">
-            <a:avLst/>
-          </a:prstGeom>
-          <a:noFill/>
-          <a:ln/>
-        </p:spPr>
-        <p:txBody>
-          <a:bodyPr wrap="square" lIns="0" tIns="0" rIns="0" bIns="0" rtlCol="0" anchor="ctr"/>
-          <a:lstStyle/>
-          <a:p>
-            <a:pPr indent="0" marL="0">
-              <a:buNone/>
-            </a:pPr>
-            <a:r>
-              <a:rPr lang="en-US" sz="1100" dirty="0">
-                <a:solidFill>
-                  <a:srgbClr val="000000"/>
-                </a:solidFill>
-                <a:latin typeface="JetBrains Mono" pitchFamily="34" charset="0"/>
-                <a:ea typeface="JetBrains Mono" pitchFamily="34" charset="-122"/>
-                <a:cs typeface="JetBrains Mono" pitchFamily="34" charset="-120"/>
-              </a:rPr>
-              <a:t>2 / 5</a:t>
-            </a:r>
-            <a:endParaRPr lang="en-US" sz="1100" dirty="0"/>
-          </a:p>
-        </p:txBody>
-      </p:sp>
-      <p:pic>
-        <p:nvPicPr>
-          <p:cNvPr id="12" name="Image 1" descr="/home/user/data-manipulation-exercises/.claude/skills/brand-guidelines/assets/textures/arrow-black.png">    </p:cNvPr>
+          <p:cNvPr id="8" name="Image 1" descr="/home/user/data-manipulation-exercises/.claude/skills/brand-guidelines/assets/textures/globe-black.png">    </p:cNvPr>
           <p:cNvPicPr>
             <a:picLocks noChangeAspect="1"/>
           </p:cNvPicPr>
@@ -4441,8 +4267,205 @@
           </a:stretch>
         </p:blipFill>
         <p:spPr>
+          <a:xfrm>
+            <a:off x="5403098" y="6207404"/>
+            <a:ext cx="249631" cy="249631"/>
+          </a:xfrm>
+          <a:prstGeom prst="rect">
+            <a:avLst/>
+          </a:prstGeom>
+        </p:spPr>
+      </p:pic>
+      <p:sp>
+        <p:nvSpPr>
+          <p:cNvPr id="9" name="Text 5"/>
+          <p:cNvSpPr/>
+          <p:nvPr/>
+        </p:nvSpPr>
+        <p:spPr>
+          <a:xfrm>
+            <a:off x="640080" y="6720840"/>
+            <a:ext cx="6949440" cy="1097280"/>
+          </a:xfrm>
+          <a:prstGeom prst="rect">
+            <a:avLst/>
+          </a:prstGeom>
+          <a:noFill/>
+          <a:ln/>
+        </p:spPr>
+        <p:txBody>
+          <a:bodyPr wrap="square" lIns="0" tIns="0" rIns="0" bIns="0" rtlCol="0" anchor="t"/>
+          <a:lstStyle/>
+          <a:p>
+            <a:pPr algn="l" indent="0" marL="0">
+              <a:buNone/>
+            </a:pPr>
+            <a:r>
+              <a:rPr lang="en-US" sz="3000" b="1" i="1" dirty="0">
+                <a:solidFill>
+                  <a:srgbClr val="000000"/>
+                </a:solidFill>
+                <a:latin typeface="Libre Baskerville" pitchFamily="34" charset="0"/>
+                <a:ea typeface="Libre Baskerville" pitchFamily="34" charset="-122"/>
+                <a:cs typeface="Libre Baskerville" pitchFamily="34" charset="-120"/>
+              </a:rPr>
+              <a:t>AGENTIC</a:t>
+            </a:r>
+            <a:endParaRPr lang="en-US" sz="3000" dirty="0"/>
+          </a:p>
+          <a:p>
+            <a:pPr algn="l" indent="0" marL="0">
+              <a:buNone/>
+            </a:pPr>
+            <a:r>
+              <a:rPr lang="en-US" sz="3000" b="1" i="1" dirty="0">
+                <a:solidFill>
+                  <a:srgbClr val="000000"/>
+                </a:solidFill>
+                <a:latin typeface="Libre Baskerville" pitchFamily="34" charset="0"/>
+                <a:ea typeface="Libre Baskerville" pitchFamily="34" charset="-122"/>
+                <a:cs typeface="Libre Baskerville" pitchFamily="34" charset="-120"/>
+              </a:rPr>
+              <a:t>SEARCH</a:t>
+            </a:r>
+            <a:endParaRPr lang="en-US" sz="3000" dirty="0"/>
+          </a:p>
+        </p:txBody>
+      </p:sp>
+      <p:sp>
+        <p:nvSpPr>
+          <p:cNvPr id="10" name="Text 6"/>
+          <p:cNvSpPr/>
+          <p:nvPr/>
+        </p:nvSpPr>
+        <p:spPr>
+          <a:xfrm>
+            <a:off x="640080" y="7955280"/>
+            <a:ext cx="6949440" cy="822960"/>
+          </a:xfrm>
+          <a:prstGeom prst="rect">
+            <a:avLst/>
+          </a:prstGeom>
+          <a:noFill/>
+          <a:ln/>
+        </p:spPr>
+        <p:txBody>
+          <a:bodyPr wrap="square" lIns="0" tIns="0" rIns="0" bIns="0" rtlCol="0" anchor="t"/>
+          <a:lstStyle/>
+          <a:p>
+            <a:pPr algn="l" indent="0" marL="0">
+              <a:buNone/>
+            </a:pPr>
+            <a:r>
+              <a:rPr lang="en-US" sz="1500" b="1" dirty="0">
+                <a:solidFill>
+                  <a:srgbClr val="000000"/>
+                </a:solidFill>
+                <a:latin typeface="Arial" pitchFamily="34" charset="0"/>
+                <a:ea typeface="Arial" pitchFamily="34" charset="-122"/>
+                <a:cs typeface="Arial" pitchFamily="34" charset="-120"/>
+              </a:rPr>
+              <a:t>Sua marca já apareceu numa resposta de IA hoje?</a:t>
+            </a:r>
+            <a:endParaRPr lang="en-US" sz="1500" dirty="0"/>
+          </a:p>
+        </p:txBody>
+      </p:sp>
+      <p:sp>
+        <p:nvSpPr>
+          <p:cNvPr id="11" name="Text 7"/>
+          <p:cNvSpPr/>
+          <p:nvPr/>
+        </p:nvSpPr>
+        <p:spPr>
+          <a:xfrm>
+            <a:off x="640080" y="8915400"/>
+            <a:ext cx="6492240" cy="594360"/>
+          </a:xfrm>
+          <a:prstGeom prst="rect">
+            <a:avLst/>
+          </a:prstGeom>
+          <a:noFill/>
+          <a:ln/>
+        </p:spPr>
+        <p:txBody>
+          <a:bodyPr wrap="square" lIns="0" tIns="0" rIns="0" bIns="0" rtlCol="0" anchor="t"/>
+          <a:lstStyle/>
+          <a:p>
+            <a:pPr algn="l" indent="0" marL="0">
+              <a:buNone/>
+            </a:pPr>
+            <a:r>
+              <a:rPr lang="en-US" sz="1000" dirty="0">
+                <a:solidFill>
+                  <a:srgbClr val="000000"/>
+                </a:solidFill>
+                <a:latin typeface="JetBrains Mono" pitchFamily="34" charset="0"/>
+                <a:ea typeface="JetBrains Mono" pitchFamily="34" charset="-122"/>
+                <a:cs typeface="JetBrains Mono" pitchFamily="34" charset="-120"/>
+              </a:rPr>
+              <a:t>Buscas por IA para descobrir produtos cresceram 200% em 1 ano.</a:t>
+            </a:r>
+            <a:endParaRPr lang="en-US" sz="1000" dirty="0"/>
+          </a:p>
+        </p:txBody>
+      </p:sp>
+      <p:sp>
+        <p:nvSpPr>
+          <p:cNvPr id="12" name="Text 8"/>
+          <p:cNvSpPr/>
+          <p:nvPr/>
+        </p:nvSpPr>
+        <p:spPr>
+          <a:xfrm>
+            <a:off x="640080" y="9692640"/>
+            <a:ext cx="1828800" cy="320040"/>
+          </a:xfrm>
+          <a:prstGeom prst="rect">
+            <a:avLst/>
+          </a:prstGeom>
+          <a:noFill/>
+          <a:ln/>
+        </p:spPr>
+        <p:txBody>
+          <a:bodyPr wrap="square" lIns="0" tIns="0" rIns="0" bIns="0" rtlCol="0" anchor="ctr"/>
+          <a:lstStyle/>
+          <a:p>
+            <a:pPr indent="0" marL="0">
+              <a:buNone/>
+            </a:pPr>
+            <a:r>
+              <a:rPr lang="en-US" sz="1000" dirty="0">
+                <a:solidFill>
+                  <a:srgbClr val="000000"/>
+                </a:solidFill>
+                <a:latin typeface="JetBrains Mono" pitchFamily="34" charset="0"/>
+                <a:ea typeface="JetBrains Mono" pitchFamily="34" charset="-122"/>
+                <a:cs typeface="JetBrains Mono" pitchFamily="34" charset="-120"/>
+              </a:rPr>
+              <a:t>2 / 5</a:t>
+            </a:r>
+            <a:endParaRPr lang="en-US" sz="1000" dirty="0"/>
+          </a:p>
+        </p:txBody>
+      </p:sp>
+      <p:pic>
+        <p:nvPicPr>
+          <p:cNvPr id="13" name="Image 2" descr="/home/user/data-manipulation-exercises/.claude/skills/brand-guidelines/assets/textures/arrow-black.png">    </p:cNvPr>
+          <p:cNvPicPr>
+            <a:picLocks noChangeAspect="1"/>
+          </p:cNvPicPr>
+          <p:nvPr/>
+        </p:nvPicPr>
+        <p:blipFill>
+          <a:blip r:embed="rId3"/>
+          <a:stretch>
+            <a:fillRect/>
+          </a:stretch>
+        </p:blipFill>
+        <p:spPr>
           <a:xfrm rot="5400000">
-            <a:off x="7223760" y="9281160"/>
+            <a:off x="7223760" y="9628632"/>
             <a:ext cx="292608" cy="292608"/>
           </a:xfrm>
           <a:prstGeom prst="rect">

</xml_diff>

<commit_message>
Frame the Agentic Search photo like the other cards, warm up the caption
The ChatGPT photo now sits in the same inset rounded-rectangle frame as
the other trend cards instead of bleeding to the slide edges. Rewrites
the Instagram caption in a more personal, conversational voice and drops
the technical-sounding language (data/source callouts, ".report mensal",
english hashtag) in favor of plain talk, still brand-voice compliant.
</commit_message>
<xml_diff>
--- a/entregas-agosto26/carrossel-instagram-agosto26.pptx
+++ b/entregas-agosto26/carrossel-instagram-agosto26.pptx
@@ -3658,7 +3658,7 @@
         </p:nvSpPr>
         <p:spPr>
           <a:xfrm>
-            <a:off x="411480" y="662940"/>
+            <a:off x="411480" y="9349740"/>
             <a:ext cx="274320" cy="274320"/>
           </a:xfrm>
           <a:prstGeom prst="rect">
@@ -3697,7 +3697,7 @@
         </p:nvSpPr>
         <p:spPr>
           <a:xfrm>
-            <a:off x="2011680" y="662940"/>
+            <a:off x="2011680" y="9349740"/>
             <a:ext cx="274320" cy="274320"/>
           </a:xfrm>
           <a:prstGeom prst="rect">
@@ -3736,7 +3736,7 @@
         </p:nvSpPr>
         <p:spPr>
           <a:xfrm>
-            <a:off x="3611880" y="662940"/>
+            <a:off x="3611880" y="9349740"/>
             <a:ext cx="274320" cy="274320"/>
           </a:xfrm>
           <a:prstGeom prst="rect">
@@ -3775,7 +3775,7 @@
         </p:nvSpPr>
         <p:spPr>
           <a:xfrm>
-            <a:off x="5212080" y="662940"/>
+            <a:off x="5212080" y="9349740"/>
             <a:ext cx="274320" cy="274320"/>
           </a:xfrm>
           <a:prstGeom prst="rect">
@@ -3822,7 +3822,7 @@
         </p:blipFill>
         <p:spPr>
           <a:xfrm>
-            <a:off x="7315200" y="548640"/>
+            <a:off x="7315200" y="9235440"/>
             <a:ext cx="502920" cy="502920"/>
           </a:xfrm>
           <a:prstGeom prst="rect">
@@ -3838,12 +3838,12 @@
         </p:nvSpPr>
         <p:spPr>
           <a:xfrm>
-            <a:off x="411480" y="1444752"/>
-            <a:ext cx="7406640" cy="2990088"/>
+            <a:off x="411480" y="365760"/>
+            <a:ext cx="7406640" cy="8293608"/>
           </a:xfrm>
           <a:prstGeom prst="roundRect">
             <a:avLst>
-              <a:gd name="adj" fmla="val 7645"/>
+              <a:gd name="adj" fmla="val 3086"/>
             </a:avLst>
           </a:prstGeom>
           <a:solidFill>
@@ -3860,7 +3860,7 @@
         </p:nvSpPr>
         <p:spPr>
           <a:xfrm>
-            <a:off x="731520" y="1719072"/>
+            <a:off x="731520" y="640080"/>
             <a:ext cx="6766560" cy="502920"/>
           </a:xfrm>
           <a:prstGeom prst="rect">
@@ -3899,7 +3899,7 @@
         </p:nvSpPr>
         <p:spPr>
           <a:xfrm>
-            <a:off x="548640" y="2221992"/>
+            <a:off x="548640" y="1143000"/>
             <a:ext cx="7132320" cy="566928"/>
           </a:xfrm>
           <a:prstGeom prst="ellipse">
@@ -3921,7 +3921,7 @@
         </p:nvSpPr>
         <p:spPr>
           <a:xfrm>
-            <a:off x="548640" y="2221992"/>
+            <a:off x="548640" y="1143000"/>
             <a:ext cx="7132320" cy="566928"/>
           </a:xfrm>
           <a:prstGeom prst="rect">
@@ -3952,87 +3952,9 @@
           </a:p>
         </p:txBody>
       </p:sp>
-      <p:sp>
-        <p:nvSpPr>
-          <p:cNvPr id="11" name="Text 8"/>
-          <p:cNvSpPr/>
-          <p:nvPr/>
-        </p:nvSpPr>
-        <p:spPr>
-          <a:xfrm>
-            <a:off x="731520" y="3017520"/>
-            <a:ext cx="6766560" cy="777240"/>
-          </a:xfrm>
-          <a:prstGeom prst="rect">
-            <a:avLst/>
-          </a:prstGeom>
-          <a:noFill/>
-          <a:ln/>
-        </p:spPr>
-        <p:txBody>
-          <a:bodyPr wrap="square" lIns="0" tIns="0" rIns="0" bIns="0" rtlCol="0" anchor="t"/>
-          <a:lstStyle/>
-          <a:p>
-            <a:pPr algn="l" indent="0" marL="0">
-              <a:buNone/>
-            </a:pPr>
-            <a:r>
-              <a:rPr lang="en-US" sz="1400" b="1" dirty="0">
-                <a:solidFill>
-                  <a:srgbClr val="FF7C51"/>
-                </a:solidFill>
-                <a:latin typeface="Arial" pitchFamily="34" charset="0"/>
-                <a:ea typeface="Arial" pitchFamily="34" charset="-122"/>
-                <a:cs typeface="Arial" pitchFamily="34" charset="-120"/>
-              </a:rPr>
-              <a:t>Sua marca já apareceu numa resposta de IA hoje?</a:t>
-            </a:r>
-            <a:endParaRPr lang="en-US" sz="1400" dirty="0"/>
-          </a:p>
-        </p:txBody>
-      </p:sp>
-      <p:sp>
-        <p:nvSpPr>
-          <p:cNvPr id="12" name="Text 9"/>
-          <p:cNvSpPr/>
-          <p:nvPr/>
-        </p:nvSpPr>
-        <p:spPr>
-          <a:xfrm>
-            <a:off x="731520" y="3703320"/>
-            <a:ext cx="6766560" cy="594360"/>
-          </a:xfrm>
-          <a:prstGeom prst="rect">
-            <a:avLst/>
-          </a:prstGeom>
-          <a:noFill/>
-          <a:ln/>
-        </p:spPr>
-        <p:txBody>
-          <a:bodyPr wrap="square" lIns="0" tIns="0" rIns="0" bIns="0" rtlCol="0" anchor="t"/>
-          <a:lstStyle/>
-          <a:p>
-            <a:pPr algn="l" indent="0" marL="0">
-              <a:buNone/>
-            </a:pPr>
-            <a:r>
-              <a:rPr lang="en-US" sz="1000" dirty="0">
-                <a:solidFill>
-                  <a:srgbClr val="FF7C51"/>
-                </a:solidFill>
-                <a:latin typeface="JetBrains Mono" pitchFamily="34" charset="0"/>
-                <a:ea typeface="JetBrains Mono" pitchFamily="34" charset="-122"/>
-                <a:cs typeface="JetBrains Mono" pitchFamily="34" charset="-120"/>
-              </a:rPr>
-              <a:t>Buscas por IA para descobrir produtos cresceram 200% em 1 ano.</a:t>
-            </a:r>
-            <a:endParaRPr lang="en-US" sz="1000" dirty="0"/>
-          </a:p>
-        </p:txBody>
-      </p:sp>
       <p:pic>
         <p:nvPicPr>
-          <p:cNvPr id="13" name="Image 1" descr="/tmp/claude-0/-home-user-data-manipulation-exercises/f19acac8-ccb4-5197-8e49-c3b6029ad477/scratchpad/report-images/final/ig-agentic-search.jpg">    </p:cNvPr>
+          <p:cNvPr id="11" name="Image 1" descr="/tmp/claude-0/-home-user-data-manipulation-exercises/f19acac8-ccb4-5197-8e49-c3b6029ad477/scratchpad/report-images/final/ig-agentic-search.jpg">    </p:cNvPr>
           <p:cNvPicPr>
             <a:picLocks noChangeAspect="1"/>
           </p:cNvPicPr>
@@ -4045,14 +3967,92 @@
         </p:blipFill>
         <p:spPr>
           <a:xfrm>
-            <a:off x="0" y="4389120"/>
-            <a:ext cx="8229600" cy="5897880"/>
+            <a:off x="731520" y="1938528"/>
+            <a:ext cx="6766560" cy="5029200"/>
           </a:xfrm>
           <a:prstGeom prst="rect">
             <a:avLst/>
           </a:prstGeom>
         </p:spPr>
       </p:pic>
+      <p:sp>
+        <p:nvSpPr>
+          <p:cNvPr id="12" name="Text 8"/>
+          <p:cNvSpPr/>
+          <p:nvPr/>
+        </p:nvSpPr>
+        <p:spPr>
+          <a:xfrm>
+            <a:off x="731520" y="7242048"/>
+            <a:ext cx="6766560" cy="777240"/>
+          </a:xfrm>
+          <a:prstGeom prst="rect">
+            <a:avLst/>
+          </a:prstGeom>
+          <a:noFill/>
+          <a:ln/>
+        </p:spPr>
+        <p:txBody>
+          <a:bodyPr wrap="square" lIns="0" tIns="0" rIns="0" bIns="0" rtlCol="0" anchor="t"/>
+          <a:lstStyle/>
+          <a:p>
+            <a:pPr algn="l" indent="0" marL="0">
+              <a:buNone/>
+            </a:pPr>
+            <a:r>
+              <a:rPr lang="en-US" sz="1400" b="1" dirty="0">
+                <a:solidFill>
+                  <a:srgbClr val="FF7C51"/>
+                </a:solidFill>
+                <a:latin typeface="Arial" pitchFamily="34" charset="0"/>
+                <a:ea typeface="Arial" pitchFamily="34" charset="-122"/>
+                <a:cs typeface="Arial" pitchFamily="34" charset="-120"/>
+              </a:rPr>
+              <a:t>Sua marca já apareceu numa resposta de IA hoje?</a:t>
+            </a:r>
+            <a:endParaRPr lang="en-US" sz="1400" dirty="0"/>
+          </a:p>
+        </p:txBody>
+      </p:sp>
+      <p:sp>
+        <p:nvSpPr>
+          <p:cNvPr id="13" name="Text 9"/>
+          <p:cNvSpPr/>
+          <p:nvPr/>
+        </p:nvSpPr>
+        <p:spPr>
+          <a:xfrm>
+            <a:off x="731520" y="7927848"/>
+            <a:ext cx="6766560" cy="594360"/>
+          </a:xfrm>
+          <a:prstGeom prst="rect">
+            <a:avLst/>
+          </a:prstGeom>
+          <a:noFill/>
+          <a:ln/>
+        </p:spPr>
+        <p:txBody>
+          <a:bodyPr wrap="square" lIns="0" tIns="0" rIns="0" bIns="0" rtlCol="0" anchor="t"/>
+          <a:lstStyle/>
+          <a:p>
+            <a:pPr algn="l" indent="0" marL="0">
+              <a:buNone/>
+            </a:pPr>
+            <a:r>
+              <a:rPr lang="en-US" sz="1000" dirty="0">
+                <a:solidFill>
+                  <a:srgbClr val="FF7C51"/>
+                </a:solidFill>
+                <a:latin typeface="JetBrains Mono" pitchFamily="34" charset="0"/>
+                <a:ea typeface="JetBrains Mono" pitchFamily="34" charset="-122"/>
+                <a:cs typeface="JetBrains Mono" pitchFamily="34" charset="-120"/>
+              </a:rPr>
+              <a:t>Buscas por IA para descobrir produtos cresceram 200% em 1 ano.</a:t>
+            </a:r>
+            <a:endParaRPr lang="en-US" sz="1000" dirty="0"/>
+          </a:p>
+        </p:txBody>
+      </p:sp>
     </p:spTree>
   </p:cSld>
   <p:clrMapOvr>

</xml_diff>

<commit_message>
Add a detail sentence to each trend card for more context
Each card now carries headline + a short expanding sentence + the
data/source line, instead of just headline + data point. Tightened the
photo-mid variant's inset photo slightly and widened the text block's
vertical budget so the longest headline (Sport Fandom, which wraps to
two lines) no longer crowds the detail text below it.
</commit_message>
<xml_diff>
--- a/entregas-agosto26/carrossel-instagram-agosto26.pptx
+++ b/entregas-agosto26/carrossel-instagram-agosto26.pptx
@@ -3404,7 +3404,7 @@
         <p:spPr>
           <a:xfrm>
             <a:off x="411480" y="365760"/>
-            <a:ext cx="7406640" cy="8293608"/>
+            <a:ext cx="7406640" cy="8247888"/>
           </a:xfrm>
           <a:prstGeom prst="roundRect">
             <a:avLst>
@@ -3533,7 +3533,7 @@
         <p:spPr>
           <a:xfrm>
             <a:off x="731520" y="1938528"/>
-            <a:ext cx="6766560" cy="5029200"/>
+            <a:ext cx="6766560" cy="4114800"/>
           </a:xfrm>
           <a:prstGeom prst="rect">
             <a:avLst/>
@@ -3548,8 +3548,8 @@
         </p:nvSpPr>
         <p:spPr>
           <a:xfrm>
-            <a:off x="731520" y="7242048"/>
-            <a:ext cx="6766560" cy="777240"/>
+            <a:off x="731520" y="6327648"/>
+            <a:ext cx="6766560" cy="731520"/>
           </a:xfrm>
           <a:prstGeom prst="rect">
             <a:avLst/>
@@ -3587,8 +3587,47 @@
         </p:nvSpPr>
         <p:spPr>
           <a:xfrm>
-            <a:off x="731520" y="7927848"/>
-            <a:ext cx="6766560" cy="594360"/>
+            <a:off x="731520" y="7059168"/>
+            <a:ext cx="6766560" cy="914400"/>
+          </a:xfrm>
+          <a:prstGeom prst="rect">
+            <a:avLst/>
+          </a:prstGeom>
+          <a:noFill/>
+          <a:ln/>
+        </p:spPr>
+        <p:txBody>
+          <a:bodyPr wrap="square" lIns="0" tIns="0" rIns="0" bIns="0" rtlCol="0" anchor="t"/>
+          <a:lstStyle/>
+          <a:p>
+            <a:pPr algn="l" indent="0" marL="0">
+              <a:buNone/>
+            </a:pPr>
+            <a:r>
+              <a:rPr lang="en-US" sz="1100" dirty="0">
+                <a:solidFill>
+                  <a:srgbClr val="DAFF94"/>
+                </a:solidFill>
+                <a:latin typeface="Arial" pitchFamily="34" charset="0"/>
+                <a:ea typeface="Arial" pitchFamily="34" charset="-122"/>
+                <a:cs typeface="Arial" pitchFamily="34" charset="-120"/>
+              </a:rPr>
+              <a:t>Filtros, avatares e IA generativa já fazem parte de como essa geração se relaciona, compra e se expressa — sem hierarquia entre o que é “real” e o que é digital.</a:t>
+            </a:r>
+            <a:endParaRPr lang="en-US" sz="1100" dirty="0"/>
+          </a:p>
+        </p:txBody>
+      </p:sp>
+      <p:sp>
+        <p:nvSpPr>
+          <p:cNvPr id="14" name="Text 10"/>
+          <p:cNvSpPr/>
+          <p:nvPr/>
+        </p:nvSpPr>
+        <p:spPr>
+          <a:xfrm>
+            <a:off x="731520" y="7973568"/>
+            <a:ext cx="6766560" cy="548640"/>
           </a:xfrm>
           <a:prstGeom prst="rect">
             <a:avLst/>
@@ -3839,7 +3878,7 @@
         <p:spPr>
           <a:xfrm>
             <a:off x="411480" y="365760"/>
-            <a:ext cx="7406640" cy="8293608"/>
+            <a:ext cx="7406640" cy="8247888"/>
           </a:xfrm>
           <a:prstGeom prst="roundRect">
             <a:avLst>
@@ -3968,7 +4007,7 @@
         <p:spPr>
           <a:xfrm>
             <a:off x="731520" y="1938528"/>
-            <a:ext cx="6766560" cy="5029200"/>
+            <a:ext cx="6766560" cy="4114800"/>
           </a:xfrm>
           <a:prstGeom prst="rect">
             <a:avLst/>
@@ -3983,8 +4022,8 @@
         </p:nvSpPr>
         <p:spPr>
           <a:xfrm>
-            <a:off x="731520" y="7242048"/>
-            <a:ext cx="6766560" cy="777240"/>
+            <a:off x="731520" y="6327648"/>
+            <a:ext cx="6766560" cy="731520"/>
           </a:xfrm>
           <a:prstGeom prst="rect">
             <a:avLst/>
@@ -4022,8 +4061,47 @@
         </p:nvSpPr>
         <p:spPr>
           <a:xfrm>
-            <a:off x="731520" y="7927848"/>
-            <a:ext cx="6766560" cy="594360"/>
+            <a:off x="731520" y="7059168"/>
+            <a:ext cx="6766560" cy="914400"/>
+          </a:xfrm>
+          <a:prstGeom prst="rect">
+            <a:avLst/>
+          </a:prstGeom>
+          <a:noFill/>
+          <a:ln/>
+        </p:spPr>
+        <p:txBody>
+          <a:bodyPr wrap="square" lIns="0" tIns="0" rIns="0" bIns="0" rtlCol="0" anchor="t"/>
+          <a:lstStyle/>
+          <a:p>
+            <a:pPr algn="l" indent="0" marL="0">
+              <a:buNone/>
+            </a:pPr>
+            <a:r>
+              <a:rPr lang="en-US" sz="1100" dirty="0">
+                <a:solidFill>
+                  <a:srgbClr val="FF7C51"/>
+                </a:solidFill>
+                <a:latin typeface="Arial" pitchFamily="34" charset="0"/>
+                <a:ea typeface="Arial" pitchFamily="34" charset="-122"/>
+                <a:cs typeface="Arial" pitchFamily="34" charset="-120"/>
+              </a:rPr>
+              <a:t>Ferramentas como ChatGPT e Perplexity viraram ponto de partida de pesquisa antes da compra — estar bem descrito nelas já pesa tanto quanto estar bem posicionado no Google.</a:t>
+            </a:r>
+            <a:endParaRPr lang="en-US" sz="1100" dirty="0"/>
+          </a:p>
+        </p:txBody>
+      </p:sp>
+      <p:sp>
+        <p:nvSpPr>
+          <p:cNvPr id="14" name="Text 10"/>
+          <p:cNvSpPr/>
+          <p:nvPr/>
+        </p:nvSpPr>
+        <p:spPr>
+          <a:xfrm>
+            <a:off x="731520" y="7973568"/>
+            <a:ext cx="6766560" cy="548640"/>
           </a:xfrm>
           <a:prstGeom prst="rect">
             <a:avLst/>
@@ -4274,7 +4352,7 @@
         <p:spPr>
           <a:xfrm>
             <a:off x="411480" y="365760"/>
-            <a:ext cx="7406640" cy="8293608"/>
+            <a:ext cx="7406640" cy="8247888"/>
           </a:xfrm>
           <a:prstGeom prst="roundRect">
             <a:avLst>
@@ -4403,7 +4481,7 @@
         <p:spPr>
           <a:xfrm>
             <a:off x="731520" y="1938528"/>
-            <a:ext cx="6766560" cy="5029200"/>
+            <a:ext cx="6766560" cy="4114800"/>
           </a:xfrm>
           <a:prstGeom prst="rect">
             <a:avLst/>
@@ -4418,8 +4496,8 @@
         </p:nvSpPr>
         <p:spPr>
           <a:xfrm>
-            <a:off x="731520" y="7242048"/>
-            <a:ext cx="6766560" cy="777240"/>
+            <a:off x="731520" y="6327648"/>
+            <a:ext cx="6766560" cy="731520"/>
           </a:xfrm>
           <a:prstGeom prst="rect">
             <a:avLst/>
@@ -4457,8 +4535,47 @@
         </p:nvSpPr>
         <p:spPr>
           <a:xfrm>
-            <a:off x="731520" y="7927848"/>
-            <a:ext cx="6766560" cy="594360"/>
+            <a:off x="731520" y="7059168"/>
+            <a:ext cx="6766560" cy="914400"/>
+          </a:xfrm>
+          <a:prstGeom prst="rect">
+            <a:avLst/>
+          </a:prstGeom>
+          <a:noFill/>
+          <a:ln/>
+        </p:spPr>
+        <p:txBody>
+          <a:bodyPr wrap="square" lIns="0" tIns="0" rIns="0" bIns="0" rtlCol="0" anchor="t"/>
+          <a:lstStyle/>
+          <a:p>
+            <a:pPr algn="l" indent="0" marL="0">
+              <a:buNone/>
+            </a:pPr>
+            <a:r>
+              <a:rPr lang="en-US" sz="1100" dirty="0">
+                <a:solidFill>
+                  <a:srgbClr val="DAFF94"/>
+                </a:solidFill>
+                <a:latin typeface="Arial" pitchFamily="34" charset="0"/>
+                <a:ea typeface="Arial" pitchFamily="34" charset="-122"/>
+                <a:cs typeface="Arial" pitchFamily="34" charset="-120"/>
+              </a:rPr>
+              <a:t>Drinks sem álcool, cervejas 0% e rótulos funcionais deixaram de ser exceção em bares e festas pra virar parte do cardápio padrão.</a:t>
+            </a:r>
+            <a:endParaRPr lang="en-US" sz="1100" dirty="0"/>
+          </a:p>
+        </p:txBody>
+      </p:sp>
+      <p:sp>
+        <p:nvSpPr>
+          <p:cNvPr id="14" name="Text 10"/>
+          <p:cNvSpPr/>
+          <p:nvPr/>
+        </p:nvSpPr>
+        <p:spPr>
+          <a:xfrm>
+            <a:off x="731520" y="7973568"/>
+            <a:ext cx="6766560" cy="548640"/>
           </a:xfrm>
           <a:prstGeom prst="rect">
             <a:avLst/>
@@ -4709,11 +4826,11 @@
         <p:spPr>
           <a:xfrm>
             <a:off x="411480" y="1444752"/>
-            <a:ext cx="7406640" cy="2990088"/>
+            <a:ext cx="7406640" cy="3858768"/>
           </a:xfrm>
           <a:prstGeom prst="roundRect">
             <a:avLst>
-              <a:gd name="adj" fmla="val 7645"/>
+              <a:gd name="adj" fmla="val 5924"/>
             </a:avLst>
           </a:prstGeom>
           <a:solidFill>
@@ -4831,7 +4948,7 @@
         <p:spPr>
           <a:xfrm>
             <a:off x="731520" y="3017520"/>
-            <a:ext cx="6766560" cy="777240"/>
+            <a:ext cx="6766560" cy="731520"/>
           </a:xfrm>
           <a:prstGeom prst="rect">
             <a:avLst/>
@@ -4869,8 +4986,47 @@
         </p:nvSpPr>
         <p:spPr>
           <a:xfrm>
-            <a:off x="731520" y="3703320"/>
-            <a:ext cx="6766560" cy="594360"/>
+            <a:off x="731520" y="3749040"/>
+            <a:ext cx="6766560" cy="914400"/>
+          </a:xfrm>
+          <a:prstGeom prst="rect">
+            <a:avLst/>
+          </a:prstGeom>
+          <a:noFill/>
+          <a:ln/>
+        </p:spPr>
+        <p:txBody>
+          <a:bodyPr wrap="square" lIns="0" tIns="0" rIns="0" bIns="0" rtlCol="0" anchor="t"/>
+          <a:lstStyle/>
+          <a:p>
+            <a:pPr algn="l" indent="0" marL="0">
+              <a:buNone/>
+            </a:pPr>
+            <a:r>
+              <a:rPr lang="en-US" sz="1100" dirty="0">
+                <a:solidFill>
+                  <a:srgbClr val="DAFF94"/>
+                </a:solidFill>
+                <a:latin typeface="Arial" pitchFamily="34" charset="0"/>
+                <a:ea typeface="Arial" pitchFamily="34" charset="-122"/>
+                <a:cs typeface="Arial" pitchFamily="34" charset="-120"/>
+              </a:rPr>
+              <a:t>Ela chega pela moda, pelos bastidores e pelas redes — e está redesenhando como marcas de esporte se comunicam e com quem.</a:t>
+            </a:r>
+            <a:endParaRPr lang="en-US" sz="1100" dirty="0"/>
+          </a:p>
+        </p:txBody>
+      </p:sp>
+      <p:sp>
+        <p:nvSpPr>
+          <p:cNvPr id="13" name="Text 10"/>
+          <p:cNvSpPr/>
+          <p:nvPr/>
+        </p:nvSpPr>
+        <p:spPr>
+          <a:xfrm>
+            <a:off x="731520" y="4663440"/>
+            <a:ext cx="6766560" cy="548640"/>
           </a:xfrm>
           <a:prstGeom prst="rect">
             <a:avLst/>
@@ -4902,7 +5058,7 @@
       </p:sp>
       <p:pic>
         <p:nvPicPr>
-          <p:cNvPr id="13" name="Image 1" descr="/tmp/claude-0/-home-user-data-manipulation-exercises/f19acac8-ccb4-5197-8e49-c3b6029ad477/scratchpad/report-images/final/ig-sport-fandom.jpg">    </p:cNvPr>
+          <p:cNvPr id="14" name="Image 1" descr="/tmp/claude-0/-home-user-data-manipulation-exercises/f19acac8-ccb4-5197-8e49-c3b6029ad477/scratchpad/report-images/final/ig-sport-fandom.jpg">    </p:cNvPr>
           <p:cNvPicPr>
             <a:picLocks noChangeAspect="1"/>
           </p:cNvPicPr>
@@ -4915,8 +5071,8 @@
         </p:blipFill>
         <p:spPr>
           <a:xfrm>
-            <a:off x="0" y="4389120"/>
-            <a:ext cx="8229600" cy="5897880"/>
+            <a:off x="0" y="5257800"/>
+            <a:ext cx="8229600" cy="5029200"/>
           </a:xfrm>
           <a:prstGeom prst="rect">
             <a:avLst/>
@@ -5144,7 +5300,7 @@
         <p:spPr>
           <a:xfrm>
             <a:off x="411480" y="365760"/>
-            <a:ext cx="7406640" cy="8293608"/>
+            <a:ext cx="7406640" cy="8247888"/>
           </a:xfrm>
           <a:prstGeom prst="roundRect">
             <a:avLst>
@@ -5273,7 +5429,7 @@
         <p:spPr>
           <a:xfrm>
             <a:off x="731520" y="1938528"/>
-            <a:ext cx="6766560" cy="5029200"/>
+            <a:ext cx="6766560" cy="4114800"/>
           </a:xfrm>
           <a:prstGeom prst="rect">
             <a:avLst/>
@@ -5288,8 +5444,8 @@
         </p:nvSpPr>
         <p:spPr>
           <a:xfrm>
-            <a:off x="731520" y="7242048"/>
-            <a:ext cx="6766560" cy="777240"/>
+            <a:off x="731520" y="6327648"/>
+            <a:ext cx="6766560" cy="731520"/>
           </a:xfrm>
           <a:prstGeom prst="rect">
             <a:avLst/>
@@ -5327,8 +5483,47 @@
         </p:nvSpPr>
         <p:spPr>
           <a:xfrm>
-            <a:off x="731520" y="7927848"/>
-            <a:ext cx="6766560" cy="594360"/>
+            <a:off x="731520" y="7059168"/>
+            <a:ext cx="6766560" cy="914400"/>
+          </a:xfrm>
+          <a:prstGeom prst="rect">
+            <a:avLst/>
+          </a:prstGeom>
+          <a:noFill/>
+          <a:ln/>
+        </p:spPr>
+        <p:txBody>
+          <a:bodyPr wrap="square" lIns="0" tIns="0" rIns="0" bIns="0" rtlCol="0" anchor="t"/>
+          <a:lstStyle/>
+          <a:p>
+            <a:pPr algn="l" indent="0" marL="0">
+              <a:buNone/>
+            </a:pPr>
+            <a:r>
+              <a:rPr lang="en-US" sz="1100" dirty="0">
+                <a:solidFill>
+                  <a:srgbClr val="FF7C51"/>
+                </a:solidFill>
+                <a:latin typeface="Arial" pitchFamily="34" charset="0"/>
+                <a:ea typeface="Arial" pitchFamily="34" charset="-122"/>
+                <a:cs typeface="Arial" pitchFamily="34" charset="-120"/>
+              </a:rPr>
+              <a:t>Retiros, jornadas de autoconhecimento e produtos com propósito de virada de chave ganham espaço à frente do consumo só por status.</a:t>
+            </a:r>
+            <a:endParaRPr lang="en-US" sz="1100" dirty="0"/>
+          </a:p>
+        </p:txBody>
+      </p:sp>
+      <p:sp>
+        <p:nvSpPr>
+          <p:cNvPr id="14" name="Text 10"/>
+          <p:cNvSpPr/>
+          <p:nvPr/>
+        </p:nvSpPr>
+        <p:spPr>
+          <a:xfrm>
+            <a:off x="731520" y="7973568"/>
+            <a:ext cx="6766560" cy="548640"/>
           </a:xfrm>
           <a:prstGeom prst="rect">
             <a:avLst/>

</xml_diff>